<commit_message>
chore: update master deck and remove stale PDF export
Updated Aegis-Master-Deck.pptx; removed the PDF export (regenerate
from the updated pptx as needed).

Co-Authored-By: Claude Opus 4.6 (1M context) <noreply@anthropic.com>
</commit_message>
<xml_diff>
--- a/Aegis-Master-Deck.pptx
+++ b/Aegis-Master-Deck.pptx
@@ -20,6 +20,7 @@
     <p:sldId id="268" r:id="rId20"/>
     <p:sldId id="269" r:id="rId21"/>
     <p:sldId id="270" r:id="rId22"/>
+    <p:sldId id="279" r:id="rId31"/>
     <p:sldId id="271" r:id="rId23"/>
     <p:sldId id="272" r:id="rId24"/>
     <p:sldId id="273" r:id="rId25"/>
@@ -5944,7 +5945,7 @@
                 </a:solidFill>
                 <a:latin typeface="Calibri"/>
               </a:rPr>
-              <a:t>   →   </a:t>
+              <a:t xml:space="preserve">   →   </a:t>
             </a:r>
             <a:r>
               <a:rPr sz="1250" b="1" i="0">
@@ -5962,7 +5963,7 @@
                 </a:solidFill>
                 <a:latin typeface="Calibri"/>
               </a:rPr>
-              <a:t>   →   </a:t>
+              <a:t xml:space="preserve">   →   </a:t>
             </a:r>
             <a:r>
               <a:rPr sz="1250" b="1" i="0">
@@ -5980,7 +5981,7 @@
                 </a:solidFill>
                 <a:latin typeface="Calibri"/>
               </a:rPr>
-              <a:t>   →   </a:t>
+              <a:t xml:space="preserve">   →   </a:t>
             </a:r>
             <a:r>
               <a:rPr sz="1250" b="0" i="0">
@@ -5998,7 +5999,7 @@
                 </a:solidFill>
                 <a:latin typeface="Calibri"/>
               </a:rPr>
-              <a:t>   →   </a:t>
+              <a:t xml:space="preserve">   →   </a:t>
             </a:r>
             <a:r>
               <a:rPr sz="1250" b="0" i="0">
@@ -6016,7 +6017,7 @@
                 </a:solidFill>
                 <a:latin typeface="Calibri"/>
               </a:rPr>
-              <a:t>   →   </a:t>
+              <a:t xml:space="preserve">   →   </a:t>
             </a:r>
             <a:r>
               <a:rPr sz="1250" b="1" i="0">
@@ -6372,7 +6373,7 @@
                 </a:solidFill>
                 <a:latin typeface="Consolas"/>
               </a:rPr>
-              <a:t>     --id billing-inquiry --owner dept-finance \</a:t>
+              <a:t xml:space="preserve">     --id billing-inquiry --owner dept-finance \</a:t>
             </a:r>
           </a:p>
           <a:p>
@@ -6394,7 +6395,7 @@
                 </a:solidFill>
                 <a:latin typeface="Consolas"/>
               </a:rPr>
-              <a:t>     --pack enterprise --blast-radius low</a:t>
+              <a:t xml:space="preserve">     --pack enterprise --blast-radius low</a:t>
             </a:r>
           </a:p>
           <a:p>
@@ -6493,7 +6494,7 @@
                 </a:solidFill>
                 <a:latin typeface="Consolas"/>
               </a:rPr>
-              <a:t>• agent.manifest.yaml  </a:t>
+              <a:t xml:space="preserve">• agent.manifest.yaml  </a:t>
             </a:r>
             <a:r>
               <a:rPr sz="1100" b="0" i="0">
@@ -6521,7 +6522,7 @@
                 </a:solidFill>
                 <a:latin typeface="Consolas"/>
               </a:rPr>
-              <a:t>• prompts/system.md  </a:t>
+              <a:t xml:space="preserve">• prompts/system.md  </a:t>
             </a:r>
             <a:r>
               <a:rPr sz="1100" b="0" i="0">
@@ -6549,7 +6550,7 @@
                 </a:solidFill>
                 <a:latin typeface="Consolas"/>
               </a:rPr>
-              <a:t>• evals/suite.md  </a:t>
+              <a:t xml:space="preserve">• evals/suite.md  </a:t>
             </a:r>
             <a:r>
               <a:rPr sz="1100" b="0" i="0">
@@ -6577,7 +6578,7 @@
                 </a:solidFill>
                 <a:latin typeface="Consolas"/>
               </a:rPr>
-              <a:t>• runbook.md  ·  README.md  </a:t>
+              <a:t xml:space="preserve">• runbook.md  ·  README.md  </a:t>
             </a:r>
             <a:r>
               <a:rPr sz="1100" b="0" i="0">
@@ -6696,7 +6697,7 @@
                 </a:solidFill>
                 <a:latin typeface="Calibri"/>
               </a:rPr>
-              <a:t>✓  </a:t>
+              <a:t xml:space="preserve">✓  </a:t>
             </a:r>
             <a:r>
               <a:rPr sz="1250" b="0" i="0">
@@ -6727,7 +6728,7 @@
                 </a:solidFill>
                 <a:latin typeface="Calibri"/>
               </a:rPr>
-              <a:t>✓  </a:t>
+              <a:t xml:space="preserve">✓  </a:t>
             </a:r>
             <a:r>
               <a:rPr sz="1250" b="0" i="0">
@@ -6758,7 +6759,7 @@
                 </a:solidFill>
                 <a:latin typeface="Calibri"/>
               </a:rPr>
-              <a:t>✓  </a:t>
+              <a:t xml:space="preserve">✓  </a:t>
             </a:r>
             <a:r>
               <a:rPr sz="1250" b="0" i="0">
@@ -6789,7 +6790,7 @@
                 </a:solidFill>
                 <a:latin typeface="Calibri"/>
               </a:rPr>
-              <a:t>✓  </a:t>
+              <a:t xml:space="preserve">✓  </a:t>
             </a:r>
             <a:r>
               <a:rPr sz="1250" b="0" i="0">
@@ -6820,7 +6821,7 @@
                 </a:solidFill>
                 <a:latin typeface="Calibri"/>
               </a:rPr>
-              <a:t>✓  </a:t>
+              <a:t xml:space="preserve">✓  </a:t>
             </a:r>
             <a:r>
               <a:rPr sz="1250" b="0" i="0">
@@ -6851,7 +6852,7 @@
                 </a:solidFill>
                 <a:latin typeface="Calibri"/>
               </a:rPr>
-              <a:t>✓  </a:t>
+              <a:t xml:space="preserve">✓  </a:t>
             </a:r>
             <a:r>
               <a:rPr sz="1250" b="0" i="0">
@@ -6882,7 +6883,7 @@
                 </a:solidFill>
                 <a:latin typeface="Calibri"/>
               </a:rPr>
-              <a:t>✓  </a:t>
+              <a:t xml:space="preserve">✓  </a:t>
             </a:r>
             <a:r>
               <a:rPr sz="1250" b="0" i="0">
@@ -6913,7 +6914,7 @@
                 </a:solidFill>
                 <a:latin typeface="Calibri"/>
               </a:rPr>
-              <a:t>✓  </a:t>
+              <a:t xml:space="preserve">✓  </a:t>
             </a:r>
             <a:r>
               <a:rPr sz="1250" b="0" i="0">
@@ -6944,7 +6945,7 @@
                 </a:solidFill>
                 <a:latin typeface="Calibri"/>
               </a:rPr>
-              <a:t>✓  </a:t>
+              <a:t xml:space="preserve">✓  </a:t>
             </a:r>
             <a:r>
               <a:rPr sz="1250" b="0" i="0">
@@ -8989,7 +8990,7 @@
                 </a:solidFill>
                 <a:latin typeface="Consolas"/>
               </a:rPr>
-              <a:t>RESULT:  </a:t>
+              <a:t xml:space="preserve">RESULT:  </a:t>
             </a:r>
             <a:r>
               <a:rPr sz="1500" b="1" i="0">
@@ -9007,7 +9008,7 @@
                 </a:solidFill>
                 <a:latin typeface="Consolas"/>
               </a:rPr>
-              <a:t>     ·  exits non-zero if any step fails</a:t>
+              <a:t xml:space="preserve">     ·  exits non-zero if any step fails</a:t>
             </a:r>
           </a:p>
         </p:txBody>
@@ -9052,7 +9053,7 @@
                 </a:solidFill>
                 <a:latin typeface="Calibri"/>
               </a:rPr>
-              <a:t>✓  </a:t>
+              <a:t xml:space="preserve">✓  </a:t>
             </a:r>
             <a:r>
               <a:rPr sz="1200" b="0" i="0">
@@ -9106,7 +9107,7 @@
                 </a:solidFill>
                 <a:latin typeface="Calibri"/>
               </a:rPr>
-              <a:t>✓  </a:t>
+              <a:t xml:space="preserve">✓  </a:t>
             </a:r>
             <a:r>
               <a:rPr sz="1200" b="0" i="0">
@@ -9160,7 +9161,7 @@
                 </a:solidFill>
                 <a:latin typeface="Calibri"/>
               </a:rPr>
-              <a:t>✓  </a:t>
+              <a:t xml:space="preserve">✓  </a:t>
             </a:r>
             <a:r>
               <a:rPr sz="1200" b="0" i="0">
@@ -9214,7 +9215,7 @@
                 </a:solidFill>
                 <a:latin typeface="Calibri"/>
               </a:rPr>
-              <a:t>✓  </a:t>
+              <a:t xml:space="preserve">✓  </a:t>
             </a:r>
             <a:r>
               <a:rPr sz="1200" b="0" i="0">
@@ -9268,7 +9269,7 @@
                 </a:solidFill>
                 <a:latin typeface="Calibri"/>
               </a:rPr>
-              <a:t>✓  </a:t>
+              <a:t xml:space="preserve">✓  </a:t>
             </a:r>
             <a:r>
               <a:rPr sz="1200" b="0" i="0">
@@ -9322,7 +9323,7 @@
                 </a:solidFill>
                 <a:latin typeface="Calibri"/>
               </a:rPr>
-              <a:t>✓  </a:t>
+              <a:t xml:space="preserve">✓  </a:t>
             </a:r>
             <a:r>
               <a:rPr sz="1200" b="0" i="0">
@@ -9672,7 +9673,7 @@
                 </a:solidFill>
                 <a:latin typeface="Calibri"/>
               </a:rPr>
-              <a:t>✓  </a:t>
+              <a:t xml:space="preserve">✓  </a:t>
             </a:r>
             <a:r>
               <a:rPr sz="1150" b="0" i="0">
@@ -9703,7 +9704,7 @@
                 </a:solidFill>
                 <a:latin typeface="Calibri"/>
               </a:rPr>
-              <a:t>✓  </a:t>
+              <a:t xml:space="preserve">✓  </a:t>
             </a:r>
             <a:r>
               <a:rPr sz="1150" b="0" i="0">
@@ -9734,7 +9735,7 @@
                 </a:solidFill>
                 <a:latin typeface="Calibri"/>
               </a:rPr>
-              <a:t>✓  </a:t>
+              <a:t xml:space="preserve">✓  </a:t>
             </a:r>
             <a:r>
               <a:rPr sz="1150" b="0" i="0">
@@ -9765,7 +9766,7 @@
                 </a:solidFill>
                 <a:latin typeface="Calibri"/>
               </a:rPr>
-              <a:t>✓  </a:t>
+              <a:t xml:space="preserve">✓  </a:t>
             </a:r>
             <a:r>
               <a:rPr sz="1150" b="0" i="0">
@@ -9796,7 +9797,7 @@
                 </a:solidFill>
                 <a:latin typeface="Calibri"/>
               </a:rPr>
-              <a:t>✓  </a:t>
+              <a:t xml:space="preserve">✓  </a:t>
             </a:r>
             <a:r>
               <a:rPr sz="1150" b="0" i="0">
@@ -9827,7 +9828,7 @@
                 </a:solidFill>
                 <a:latin typeface="Calibri"/>
               </a:rPr>
-              <a:t>✓  </a:t>
+              <a:t xml:space="preserve">✓  </a:t>
             </a:r>
             <a:r>
               <a:rPr sz="1150" b="0" i="0">
@@ -9858,7 +9859,7 @@
                 </a:solidFill>
                 <a:latin typeface="Calibri"/>
               </a:rPr>
-              <a:t>✓  </a:t>
+              <a:t xml:space="preserve">✓  </a:t>
             </a:r>
             <a:r>
               <a:rPr sz="1150" b="0" i="0">
@@ -9889,7 +9890,7 @@
                 </a:solidFill>
                 <a:latin typeface="Calibri"/>
               </a:rPr>
-              <a:t>✓  </a:t>
+              <a:t xml:space="preserve">✓  </a:t>
             </a:r>
             <a:r>
               <a:rPr sz="1150" b="0" i="0">
@@ -10006,7 +10007,7 @@
                 </a:solidFill>
                 <a:latin typeface="Calibri"/>
               </a:rPr>
-              <a:t>+  </a:t>
+              <a:t xml:space="preserve">+  </a:t>
             </a:r>
             <a:r>
               <a:rPr sz="1150" b="0" i="0">
@@ -10037,7 +10038,7 @@
                 </a:solidFill>
                 <a:latin typeface="Calibri"/>
               </a:rPr>
-              <a:t>+  </a:t>
+              <a:t xml:space="preserve">+  </a:t>
             </a:r>
             <a:r>
               <a:rPr sz="1150" b="0" i="0">
@@ -10068,7 +10069,7 @@
                 </a:solidFill>
                 <a:latin typeface="Calibri"/>
               </a:rPr>
-              <a:t>+  </a:t>
+              <a:t xml:space="preserve">+  </a:t>
             </a:r>
             <a:r>
               <a:rPr sz="1150" b="0" i="0">
@@ -10099,7 +10100,7 @@
                 </a:solidFill>
                 <a:latin typeface="Calibri"/>
               </a:rPr>
-              <a:t>+  </a:t>
+              <a:t xml:space="preserve">+  </a:t>
             </a:r>
             <a:r>
               <a:rPr sz="1150" b="0" i="0">
@@ -10130,7 +10131,7 @@
                 </a:solidFill>
                 <a:latin typeface="Calibri"/>
               </a:rPr>
-              <a:t>+  </a:t>
+              <a:t xml:space="preserve">+  </a:t>
             </a:r>
             <a:r>
               <a:rPr sz="1150" b="0" i="0">
@@ -10161,7 +10162,7 @@
                 </a:solidFill>
                 <a:latin typeface="Calibri"/>
               </a:rPr>
-              <a:t>+  </a:t>
+              <a:t xml:space="preserve">+  </a:t>
             </a:r>
             <a:r>
               <a:rPr sz="1150" b="0" i="0">
@@ -10192,7 +10193,7 @@
                 </a:solidFill>
                 <a:latin typeface="Calibri"/>
               </a:rPr>
-              <a:t>+  </a:t>
+              <a:t xml:space="preserve">+  </a:t>
             </a:r>
             <a:r>
               <a:rPr sz="1150" b="0" i="0">
@@ -10502,7 +10503,7 @@
                 </a:solidFill>
                 <a:latin typeface="Calibri"/>
               </a:rPr>
-              <a:t>✓  </a:t>
+              <a:t xml:space="preserve">✓  </a:t>
             </a:r>
             <a:r>
               <a:rPr sz="1150" b="0" i="0">
@@ -10533,7 +10534,7 @@
                 </a:solidFill>
                 <a:latin typeface="Calibri"/>
               </a:rPr>
-              <a:t>✓  </a:t>
+              <a:t xml:space="preserve">✓  </a:t>
             </a:r>
             <a:r>
               <a:rPr sz="1150" b="0" i="0">
@@ -10564,7 +10565,7 @@
                 </a:solidFill>
                 <a:latin typeface="Calibri"/>
               </a:rPr>
-              <a:t>✓  </a:t>
+              <a:t xml:space="preserve">✓  </a:t>
             </a:r>
             <a:r>
               <a:rPr sz="1150" b="0" i="0">
@@ -10595,7 +10596,7 @@
                 </a:solidFill>
                 <a:latin typeface="Calibri"/>
               </a:rPr>
-              <a:t>✓  </a:t>
+              <a:t xml:space="preserve">✓  </a:t>
             </a:r>
             <a:r>
               <a:rPr sz="1150" b="0" i="0">
@@ -10626,7 +10627,7 @@
                 </a:solidFill>
                 <a:latin typeface="Calibri"/>
               </a:rPr>
-              <a:t>✓  </a:t>
+              <a:t xml:space="preserve">✓  </a:t>
             </a:r>
             <a:r>
               <a:rPr sz="1150" b="0" i="0">
@@ -10657,7 +10658,7 @@
                 </a:solidFill>
                 <a:latin typeface="Calibri"/>
               </a:rPr>
-              <a:t>✓  </a:t>
+              <a:t xml:space="preserve">✓  </a:t>
             </a:r>
             <a:r>
               <a:rPr sz="1150" b="0" i="0">
@@ -10688,7 +10689,7 @@
                 </a:solidFill>
                 <a:latin typeface="Calibri"/>
               </a:rPr>
-              <a:t>✓  </a:t>
+              <a:t xml:space="preserve">✓  </a:t>
             </a:r>
             <a:r>
               <a:rPr sz="1150" b="0" i="0">
@@ -10719,7 +10720,7 @@
                 </a:solidFill>
                 <a:latin typeface="Calibri"/>
               </a:rPr>
-              <a:t>✓  </a:t>
+              <a:t xml:space="preserve">✓  </a:t>
             </a:r>
             <a:r>
               <a:rPr sz="1150" b="0" i="0">
@@ -10838,7 +10839,7 @@
                 </a:solidFill>
                 <a:latin typeface="Calibri"/>
               </a:rPr>
-              <a:t>○  </a:t>
+              <a:t xml:space="preserve">○  </a:t>
             </a:r>
             <a:r>
               <a:rPr sz="1150" b="0" i="0">
@@ -10869,7 +10870,7 @@
                 </a:solidFill>
                 <a:latin typeface="Calibri"/>
               </a:rPr>
-              <a:t>○  </a:t>
+              <a:t xml:space="preserve">○  </a:t>
             </a:r>
             <a:r>
               <a:rPr sz="1150" b="0" i="0">
@@ -10900,7 +10901,7 @@
                 </a:solidFill>
                 <a:latin typeface="Calibri"/>
               </a:rPr>
-              <a:t>○  </a:t>
+              <a:t xml:space="preserve">○  </a:t>
             </a:r>
             <a:r>
               <a:rPr sz="1150" b="0" i="0">
@@ -10931,7 +10932,7 @@
                 </a:solidFill>
                 <a:latin typeface="Calibri"/>
               </a:rPr>
-              <a:t>○  </a:t>
+              <a:t xml:space="preserve">○  </a:t>
             </a:r>
             <a:r>
               <a:rPr sz="1150" b="0" i="0">
@@ -10962,7 +10963,7 @@
                 </a:solidFill>
                 <a:latin typeface="Calibri"/>
               </a:rPr>
-              <a:t>○  </a:t>
+              <a:t xml:space="preserve">○  </a:t>
             </a:r>
             <a:r>
               <a:rPr sz="1150" b="0" i="0">
@@ -10993,7 +10994,7 @@
                 </a:solidFill>
                 <a:latin typeface="Calibri"/>
               </a:rPr>
-              <a:t>○  </a:t>
+              <a:t xml:space="preserve">○  </a:t>
             </a:r>
             <a:r>
               <a:rPr sz="1150" b="0" i="0">
@@ -11024,7 +11025,7 @@
                 </a:solidFill>
                 <a:latin typeface="Calibri"/>
               </a:rPr>
-              <a:t>○  </a:t>
+              <a:t xml:space="preserve">○  </a:t>
             </a:r>
             <a:r>
               <a:rPr sz="1150" b="0" i="0">
@@ -11055,7 +11056,7 @@
                 </a:solidFill>
                 <a:latin typeface="Calibri"/>
               </a:rPr>
-              <a:t>○  </a:t>
+              <a:t xml:space="preserve">○  </a:t>
             </a:r>
             <a:r>
               <a:rPr sz="1150" b="0" i="0">
@@ -11142,7 +11143,7 @@
                 </a:solidFill>
                 <a:latin typeface="Cambria"/>
               </a:rPr>
-              <a:t>"HIPAA-eligible" ≠ "HIPAA-compliant."  </a:t>
+              <a:t xml:space="preserve">"HIPAA-eligible" ≠ "HIPAA-compliant."  </a:t>
             </a:r>
             <a:r>
               <a:rPr sz="1200" b="0" i="0">
@@ -11523,7 +11524,7 @@
                 </a:solidFill>
                 <a:latin typeface="Cambria"/>
               </a:rPr>
-              <a:t>Discovery + architecture workshop   </a:t>
+              <a:t xml:space="preserve">Discovery + architecture workshop   </a:t>
             </a:r>
             <a:r>
               <a:rPr sz="1250" b="0" i="0">
@@ -11624,7 +11625,7 @@
                 </a:solidFill>
                 <a:latin typeface="Cambria"/>
               </a:rPr>
-              <a:t>Stand up the golden path   </a:t>
+              <a:t xml:space="preserve">Stand up the golden path   </a:t>
             </a:r>
             <a:r>
               <a:rPr sz="1250" b="0" i="0">
@@ -11725,7 +11726,7 @@
                 </a:solidFill>
                 <a:latin typeface="Cambria"/>
               </a:rPr>
-              <a:t>Prove a documented outcome   </a:t>
+              <a:t xml:space="preserve">Prove a documented outcome   </a:t>
             </a:r>
             <a:r>
               <a:rPr sz="1250" b="0" i="0">
@@ -11826,7 +11827,7 @@
                 </a:solidFill>
                 <a:latin typeface="Cambria"/>
               </a:rPr>
-              <a:t>Sign the shared-responsibility plan   </a:t>
+              <a:t xml:space="preserve">Sign the shared-responsibility plan   </a:t>
             </a:r>
             <a:r>
               <a:rPr sz="1250" b="0" i="0">
@@ -20488,7 +20489,7 @@
                 </a:solidFill>
                 <a:latin typeface="Calibri"/>
               </a:rPr>
-              <a:t>▪ </a:t>
+              <a:t xml:space="preserve">▪ </a:t>
             </a:r>
             <a:r>
               <a:rPr sz="1250" b="1" i="0">
@@ -20497,7 +20498,7 @@
                 </a:solidFill>
                 <a:latin typeface="Calibri"/>
               </a:rPr>
-              <a:t>Amazon Bedrock + Guardrails  </a:t>
+              <a:t xml:space="preserve">Amazon Bedrock + Guardrails  </a:t>
             </a:r>
             <a:r>
               <a:rPr sz="1100" b="0" i="0">
@@ -20525,7 +20526,7 @@
                 </a:solidFill>
                 <a:latin typeface="Calibri"/>
               </a:rPr>
-              <a:t>▪ </a:t>
+              <a:t xml:space="preserve">▪ </a:t>
             </a:r>
             <a:r>
               <a:rPr sz="1250" b="1" i="0">
@@ -20534,7 +20535,7 @@
                 </a:solidFill>
                 <a:latin typeface="Calibri"/>
               </a:rPr>
-              <a:t>AgentCore  </a:t>
+              <a:t xml:space="preserve">AgentCore  </a:t>
             </a:r>
             <a:r>
               <a:rPr sz="1100" b="0" i="0">
@@ -20562,7 +20563,7 @@
                 </a:solidFill>
                 <a:latin typeface="Calibri"/>
               </a:rPr>
-              <a:t>▪ </a:t>
+              <a:t xml:space="preserve">▪ </a:t>
             </a:r>
             <a:r>
               <a:rPr sz="1250" b="1" i="0">
@@ -20571,7 +20572,7 @@
                 </a:solidFill>
                 <a:latin typeface="Calibri"/>
               </a:rPr>
-              <a:t>AWS GovCloud (US)  </a:t>
+              <a:t xml:space="preserve">AWS GovCloud (US)  </a:t>
             </a:r>
             <a:r>
               <a:rPr sz="1100" b="0" i="0">
@@ -20599,7 +20600,7 @@
                 </a:solidFill>
                 <a:latin typeface="Calibri"/>
               </a:rPr>
-              <a:t>▪ </a:t>
+              <a:t xml:space="preserve">▪ </a:t>
             </a:r>
             <a:r>
               <a:rPr sz="1250" b="1" i="0">
@@ -20608,7 +20609,7 @@
                 </a:solidFill>
                 <a:latin typeface="Calibri"/>
               </a:rPr>
-              <a:t>KMS  </a:t>
+              <a:t xml:space="preserve">KMS  </a:t>
             </a:r>
             <a:r>
               <a:rPr sz="1100" b="0" i="0">
@@ -20636,7 +20637,7 @@
                 </a:solidFill>
                 <a:latin typeface="Calibri"/>
               </a:rPr>
-              <a:t>▪ </a:t>
+              <a:t xml:space="preserve">▪ </a:t>
             </a:r>
             <a:r>
               <a:rPr sz="1250" b="1" i="0">
@@ -20645,7 +20646,7 @@
                 </a:solidFill>
                 <a:latin typeface="Calibri"/>
               </a:rPr>
-              <a:t>Macie / Comprehend  </a:t>
+              <a:t xml:space="preserve">Macie / Comprehend  </a:t>
             </a:r>
             <a:r>
               <a:rPr sz="1100" b="0" i="0">
@@ -20673,7 +20674,7 @@
                 </a:solidFill>
                 <a:latin typeface="Calibri"/>
               </a:rPr>
-              <a:t>▪ </a:t>
+              <a:t xml:space="preserve">▪ </a:t>
             </a:r>
             <a:r>
               <a:rPr sz="1250" b="1" i="0">
@@ -20682,7 +20683,7 @@
                 </a:solidFill>
                 <a:latin typeface="Calibri"/>
               </a:rPr>
-              <a:t>FinOps stack  </a:t>
+              <a:t xml:space="preserve">FinOps stack  </a:t>
             </a:r>
             <a:r>
               <a:rPr sz="1100" b="0" i="0">
@@ -20710,7 +20711,7 @@
                 </a:solidFill>
                 <a:latin typeface="Calibri"/>
               </a:rPr>
-              <a:t>▪ </a:t>
+              <a:t xml:space="preserve">▪ </a:t>
             </a:r>
             <a:r>
               <a:rPr sz="1250" b="1" i="0">
@@ -20719,7 +20720,7 @@
                 </a:solidFill>
                 <a:latin typeface="Calibri"/>
               </a:rPr>
-              <a:t>Edge &amp; posture  </a:t>
+              <a:t xml:space="preserve">Edge &amp; posture  </a:t>
             </a:r>
             <a:r>
               <a:rPr sz="1100" b="0" i="0">
@@ -20838,7 +20839,7 @@
                 </a:solidFill>
                 <a:latin typeface="Calibri"/>
               </a:rPr>
-              <a:t>›  </a:t>
+              <a:t xml:space="preserve">›  </a:t>
             </a:r>
             <a:r>
               <a:rPr sz="1250" b="0" i="0">
@@ -20869,7 +20870,7 @@
                 </a:solidFill>
                 <a:latin typeface="Calibri"/>
               </a:rPr>
-              <a:t>›  </a:t>
+              <a:t xml:space="preserve">›  </a:t>
             </a:r>
             <a:r>
               <a:rPr sz="1250" b="0" i="0">
@@ -20900,7 +20901,7 @@
                 </a:solidFill>
                 <a:latin typeface="Calibri"/>
               </a:rPr>
-              <a:t>›  </a:t>
+              <a:t xml:space="preserve">›  </a:t>
             </a:r>
             <a:r>
               <a:rPr sz="1250" b="0" i="0">
@@ -20931,7 +20932,7 @@
                 </a:solidFill>
                 <a:latin typeface="Calibri"/>
               </a:rPr>
-              <a:t>›  </a:t>
+              <a:t xml:space="preserve">›  </a:t>
             </a:r>
             <a:r>
               <a:rPr sz="1250" b="0" i="0">
@@ -21309,7 +21310,7 @@
                 </a:solidFill>
                 <a:latin typeface="Cambria"/>
               </a:rPr>
-              <a:t>Package  </a:t>
+              <a:t xml:space="preserve">Package  </a:t>
             </a:r>
             <a:r>
               <a:rPr sz="1150" b="0" i="0">
@@ -21410,7 +21411,7 @@
                 </a:solidFill>
                 <a:latin typeface="Cambria"/>
               </a:rPr>
-              <a:t>List  </a:t>
+              <a:t xml:space="preserve">List  </a:t>
             </a:r>
             <a:r>
               <a:rPr sz="1150" b="0" i="0">
@@ -21511,7 +21512,7 @@
                 </a:solidFill>
                 <a:latin typeface="Cambria"/>
               </a:rPr>
-              <a:t>Deploy  </a:t>
+              <a:t xml:space="preserve">Deploy  </a:t>
             </a:r>
             <a:r>
               <a:rPr sz="1150" b="0" i="0">
@@ -21612,7 +21613,7 @@
                 </a:solidFill>
                 <a:latin typeface="Cambria"/>
               </a:rPr>
-              <a:t>Compound  </a:t>
+              <a:t xml:space="preserve">Compound  </a:t>
             </a:r>
             <a:r>
               <a:rPr sz="1150" b="0" i="0">
@@ -21801,7 +21802,7 @@
                 </a:solidFill>
                 <a:latin typeface="Cambria"/>
               </a:rPr>
-              <a:t>LAND  </a:t>
+              <a:t xml:space="preserve">LAND  </a:t>
             </a:r>
             <a:r>
               <a:rPr sz="1150" b="0" i="0">
@@ -21902,7 +21903,7 @@
                 </a:solidFill>
                 <a:latin typeface="Cambria"/>
               </a:rPr>
-              <a:t>PROVE  </a:t>
+              <a:t xml:space="preserve">PROVE  </a:t>
             </a:r>
             <a:r>
               <a:rPr sz="1150" b="0" i="0">
@@ -22003,7 +22004,7 @@
                 </a:solidFill>
                 <a:latin typeface="Cambria"/>
               </a:rPr>
-              <a:t>EXPAND  </a:t>
+              <a:t xml:space="preserve">EXPAND  </a:t>
             </a:r>
             <a:r>
               <a:rPr sz="1150" b="0" i="0">
@@ -22104,7 +22105,7 @@
                 </a:solidFill>
                 <a:latin typeface="Cambria"/>
               </a:rPr>
-              <a:t>ORCHESTRATE  </a:t>
+              <a:t xml:space="preserve">ORCHESTRATE  </a:t>
             </a:r>
             <a:r>
               <a:rPr sz="1150" b="0" i="0">
@@ -22201,6 +22202,733 @@
                 <a:latin typeface="Calibri"/>
               </a:rPr>
               <a:t>Aegis  ·  23</a:t>
+            </a:r>
+          </a:p>
+        </p:txBody>
+      </p:sp>
+    </p:spTree>
+  </p:cSld>
+  <p:clrMapOvr>
+    <a:masterClrMapping/>
+  </p:clrMapOvr>
+</p:sld>
+</file>
+
+<file path=ppt/slides/slide24.xml><?xml version="1.0" encoding="utf-8"?>
+<p:sld xmlns:a="http://schemas.openxmlformats.org/drawingml/2006/main" xmlns:p="http://schemas.openxmlformats.org/presentationml/2006/main" xmlns:r="http://schemas.openxmlformats.org/officeDocument/2006/relationships">
+  <p:cSld>
+    <p:spTree>
+      <p:nvGrpSpPr>
+        <p:cNvPr id="1" name=""/>
+        <p:cNvGrpSpPr/>
+        <p:nvPr/>
+      </p:nvGrpSpPr>
+      <p:grpSpPr/>
+      <p:sp>
+        <p:nvSpPr>
+          <p:cNvPr id="2" name="Background"/>
+          <p:cNvSpPr/>
+          <p:nvPr/>
+        </p:nvSpPr>
+        <p:spPr>
+          <a:xfrm>
+            <a:off x="0" y="0"/>
+            <a:ext cx="12191695" cy="6858000"/>
+          </a:xfrm>
+          <a:prstGeom prst="rect">
+            <a:avLst/>
+          </a:prstGeom>
+          <a:solidFill>
+            <a:srgbClr val="121820"/>
+          </a:solidFill>
+          <a:ln>
+            <a:noFill/>
+          </a:ln>
+          <a:effectLst/>
+        </p:spPr>
+        <p:style>
+          <a:lnRef idx="1">
+            <a:schemeClr val="accent1"/>
+          </a:lnRef>
+          <a:fillRef idx="3">
+            <a:schemeClr val="accent1"/>
+          </a:fillRef>
+          <a:effectRef idx="2">
+            <a:schemeClr val="accent1"/>
+          </a:effectRef>
+          <a:fontRef idx="minor">
+            <a:schemeClr val="lt1"/>
+          </a:fontRef>
+        </p:style>
+        <p:txBody>
+          <a:bodyPr rtlCol="0" anchor="ctr"/>
+          <a:lstStyle/>
+          <a:p>
+            <a:pPr algn="ctr"/>
+          </a:p>
+        </p:txBody>
+      </p:sp>
+      <p:sp>
+        <p:nvSpPr>
+          <p:cNvPr id="3" name="Eyebrow"/>
+          <p:cNvSpPr txBox="1"/>
+          <p:nvPr/>
+        </p:nvSpPr>
+        <p:spPr>
+          <a:xfrm>
+            <a:off x="640080" y="411480"/>
+            <a:ext cx="10881360" cy="277200"/>
+          </a:xfrm>
+          <a:prstGeom prst="rect">
+            <a:avLst/>
+          </a:prstGeom>
+          <a:noFill/>
+        </p:spPr>
+        <p:txBody>
+          <a:bodyPr wrap="square" anchor="t" lIns="0" rIns="0" tIns="0" bIns="0">
+            <a:spAutoFit/>
+          </a:bodyPr>
+          <a:lstStyle/>
+          <a:p>
+            <a:pPr algn="l">
+              <a:spcBef>
+                <a:spcPts val="0"/>
+              </a:spcBef>
+              <a:spcAft>
+                <a:spcPts val="0"/>
+              </a:spcAft>
+            </a:pPr>
+            <a:r>
+              <a:rPr sz="1250" b="1" i="0">
+                <a:solidFill>
+                  <a:srgbClr val="F5A623"/>
+                </a:solidFill>
+                <a:latin typeface="Calibri"/>
+              </a:rPr>
+              <a:t>PROVEN ON AWS</a:t>
+            </a:r>
+          </a:p>
+        </p:txBody>
+      </p:sp>
+      <p:sp>
+        <p:nvSpPr>
+          <p:cNvPr id="4" name="Title"/>
+          <p:cNvSpPr txBox="1"/>
+          <p:nvPr/>
+        </p:nvSpPr>
+        <p:spPr>
+          <a:xfrm>
+            <a:off x="640080" y="704088"/>
+            <a:ext cx="10881360" cy="512064"/>
+          </a:xfrm>
+          <a:prstGeom prst="rect">
+            <a:avLst/>
+          </a:prstGeom>
+          <a:noFill/>
+        </p:spPr>
+        <p:txBody>
+          <a:bodyPr wrap="square" anchor="t" lIns="0" rIns="0" tIns="0" bIns="0">
+            <a:spAutoFit/>
+          </a:bodyPr>
+          <a:lstStyle/>
+          <a:p>
+            <a:pPr algn="l">
+              <a:lnSpc>
+                <a:spcPct val="102000"/>
+              </a:lnSpc>
+              <a:spcBef>
+                <a:spcPts val="0"/>
+              </a:spcBef>
+              <a:spcAft>
+                <a:spcPts val="0"/>
+              </a:spcAft>
+            </a:pPr>
+            <a:r>
+              <a:rPr sz="3300" b="1" i="0">
+                <a:solidFill>
+                  <a:srgbClr val="F4F6F8"/>
+                </a:solidFill>
+                <a:latin typeface="Cambria"/>
+              </a:rPr>
+              <a:t>Proven on AWS — nine live runs</a:t>
+            </a:r>
+          </a:p>
+        </p:txBody>
+      </p:sp>
+      <p:sp>
+        <p:nvSpPr>
+          <p:cNvPr id="5" name="Subtitle"/>
+          <p:cNvSpPr txBox="1"/>
+          <p:nvPr/>
+        </p:nvSpPr>
+        <p:spPr>
+          <a:xfrm>
+            <a:off x="640080" y="1252728"/>
+            <a:ext cx="10881360" cy="329184"/>
+          </a:xfrm>
+          <a:prstGeom prst="rect">
+            <a:avLst/>
+          </a:prstGeom>
+          <a:noFill/>
+        </p:spPr>
+        <p:txBody>
+          <a:bodyPr wrap="square" anchor="t" lIns="0" rIns="0" tIns="0" bIns="0">
+            <a:spAutoFit/>
+          </a:bodyPr>
+          <a:lstStyle/>
+          <a:p>
+            <a:pPr algn="l">
+              <a:spcBef>
+                <a:spcPts val="0"/>
+              </a:spcBef>
+              <a:spcAft>
+                <a:spcPts val="0"/>
+              </a:spcAft>
+            </a:pPr>
+            <a:r>
+              <a:rPr sz="1200" b="0" i="0">
+                <a:solidFill>
+                  <a:srgbClr val="9FADBC"/>
+                </a:solidFill>
+                <a:latin typeface="Calibri"/>
+              </a:rPr>
+              <a:t>Each control deployed to a live AWS account, exercised with real requests, then torn down (account 864217980669, us-east-1).</a:t>
+            </a:r>
+          </a:p>
+        </p:txBody>
+      </p:sp>
+      <p:sp>
+        <p:nvSpPr>
+          <p:cNvPr id="6" name="LeftCard"/>
+          <p:cNvSpPr/>
+          <p:nvPr/>
+        </p:nvSpPr>
+        <p:spPr>
+          <a:xfrm>
+            <a:off x="640080" y="1691640"/>
+            <a:ext cx="5349240" cy="4023360"/>
+          </a:xfrm>
+          <a:prstGeom prst="roundRect">
+            <a:avLst/>
+          </a:prstGeom>
+          <a:solidFill>
+            <a:srgbClr val="1B242F"/>
+          </a:solidFill>
+          <a:ln w="12700">
+            <a:solidFill>
+              <a:srgbClr val="5CB85C"/>
+            </a:solidFill>
+          </a:ln>
+          <a:effectLst/>
+        </p:spPr>
+        <p:style>
+          <a:lnRef idx="1">
+            <a:schemeClr val="accent1"/>
+          </a:lnRef>
+          <a:fillRef idx="3">
+            <a:schemeClr val="accent1"/>
+          </a:fillRef>
+          <a:effectRef idx="2">
+            <a:schemeClr val="accent1"/>
+          </a:effectRef>
+          <a:fontRef idx="minor">
+            <a:schemeClr val="lt1"/>
+          </a:fontRef>
+        </p:style>
+        <p:txBody>
+          <a:bodyPr rtlCol="0" anchor="ctr"/>
+          <a:lstStyle/>
+          <a:p>
+            <a:pPr algn="ctr"/>
+          </a:p>
+        </p:txBody>
+      </p:sp>
+      <p:sp>
+        <p:nvSpPr>
+          <p:cNvPr id="7" name="LeftText"/>
+          <p:cNvSpPr txBox="1"/>
+          <p:nvPr/>
+        </p:nvSpPr>
+        <p:spPr>
+          <a:xfrm>
+            <a:off x="868680" y="1874520"/>
+            <a:ext cx="4892040" cy="3657600"/>
+          </a:xfrm>
+          <a:prstGeom prst="rect">
+            <a:avLst/>
+          </a:prstGeom>
+          <a:noFill/>
+        </p:spPr>
+        <p:txBody>
+          <a:bodyPr wrap="square" anchor="t" lIns="0" rIns="0" tIns="0" bIns="0"/>
+          <a:lstStyle/>
+          <a:p>
+            <a:pPr algn="l">
+              <a:spcBef>
+                <a:spcPts val="0"/>
+              </a:spcBef>
+              <a:spcAft>
+                <a:spcPts val="900"/>
+              </a:spcAft>
+            </a:pPr>
+            <a:r>
+              <a:rPr sz="1450" b="1" i="0">
+                <a:solidFill>
+                  <a:srgbClr val="5CB85C"/>
+                </a:solidFill>
+                <a:latin typeface="Cambria"/>
+              </a:rPr>
+              <a:t>Runs 1–5</a:t>
+            </a:r>
+          </a:p>
+          <a:p>
+            <a:pPr algn="l">
+              <a:lnSpc>
+                <a:spcPct val="106000"/>
+              </a:lnSpc>
+              <a:spcBef>
+                <a:spcPts val="0"/>
+              </a:spcBef>
+              <a:spcAft>
+                <a:spcPts val="700"/>
+              </a:spcAft>
+            </a:pPr>
+            <a:r>
+              <a:rPr sz="1150" b="1" i="0">
+                <a:solidFill>
+                  <a:srgbClr val="5CB85C"/>
+                </a:solidFill>
+                <a:latin typeface="Calibri"/>
+              </a:rPr>
+              <a:t xml:space="preserve">1  Governance core.  </a:t>
+            </a:r>
+            <a:r>
+              <a:rPr sz="1150" b="0" i="0">
+                <a:solidFill>
+                  <a:srgbClr val="F4F6F8"/>
+                </a:solidFill>
+                <a:latin typeface="Calibri"/>
+              </a:rPr>
+              <a:t>KMS CMK, append-only audit, WORM, Bedrock Guardrail, Cognito, gateway — CREATE_COMPLETE.</a:t>
+            </a:r>
+          </a:p>
+          <a:p>
+            <a:pPr algn="l">
+              <a:lnSpc>
+                <a:spcPct val="106000"/>
+              </a:lnSpc>
+              <a:spcBef>
+                <a:spcPts val="0"/>
+              </a:spcBef>
+              <a:spcAft>
+                <a:spcPts val="700"/>
+              </a:spcAft>
+            </a:pPr>
+            <a:r>
+              <a:rPr sz="1150" b="1" i="0">
+                <a:solidFill>
+                  <a:srgbClr val="5CB85C"/>
+                </a:solidFill>
+                <a:latin typeface="Calibri"/>
+              </a:rPr>
+              <a:t xml:space="preserve">2  Human gate.  </a:t>
+            </a:r>
+            <a:r>
+              <a:rPr sz="1150" b="0" i="0">
+                <a:solidFill>
+                  <a:srgbClr val="F4F6F8"/>
+                </a:solidFill>
+                <a:latin typeface="Calibri"/>
+              </a:rPr>
+              <a:t>Step Functions waitForTaskToken holds the consequential step until approval.</a:t>
+            </a:r>
+          </a:p>
+          <a:p>
+            <a:pPr algn="l">
+              <a:lnSpc>
+                <a:spcPct val="106000"/>
+              </a:lnSpc>
+              <a:spcBef>
+                <a:spcPts val="0"/>
+              </a:spcBef>
+              <a:spcAft>
+                <a:spcPts val="700"/>
+              </a:spcAft>
+            </a:pPr>
+            <a:r>
+              <a:rPr sz="1150" b="1" i="0">
+                <a:solidFill>
+                  <a:srgbClr val="5CB85C"/>
+                </a:solidFill>
+                <a:latin typeface="Calibri"/>
+              </a:rPr>
+              <a:t xml:space="preserve">3  Cedar authorization.  </a:t>
+            </a:r>
+            <a:r>
+              <a:rPr sz="1150" b="0" i="0">
+                <a:solidFill>
+                  <a:srgbClr val="F4F6F8"/>
+                </a:solidFill>
+                <a:latin typeface="Calibri"/>
+              </a:rPr>
+              <a:t>Verified Permissions + real Bedrock (Haiku 4.5) — ALLOW + 2 DENY.</a:t>
+            </a:r>
+          </a:p>
+          <a:p>
+            <a:pPr algn="l">
+              <a:lnSpc>
+                <a:spcPct val="106000"/>
+              </a:lnSpc>
+              <a:spcBef>
+                <a:spcPts val="0"/>
+              </a:spcBef>
+              <a:spcAft>
+                <a:spcPts val="700"/>
+              </a:spcAft>
+            </a:pPr>
+            <a:r>
+              <a:rPr sz="1150" b="1" i="0">
+                <a:solidFill>
+                  <a:srgbClr val="5CB85C"/>
+                </a:solidFill>
+                <a:latin typeface="Calibri"/>
+              </a:rPr>
+              <a:t xml:space="preserve">4  Hardened Cognito MFA.  </a:t>
+            </a:r>
+            <a:r>
+              <a:rPr sz="1150" b="0" i="0">
+                <a:solidFill>
+                  <a:srgbClr val="F4F6F8"/>
+                </a:solidFill>
+                <a:latin typeface="Calibri"/>
+              </a:rPr>
+              <a:t>Cryptographic JWT verification — tampered / wrong-audience tokens rejected.</a:t>
+            </a:r>
+          </a:p>
+          <a:p>
+            <a:pPr algn="l">
+              <a:lnSpc>
+                <a:spcPct val="106000"/>
+              </a:lnSpc>
+              <a:spcBef>
+                <a:spcPts val="0"/>
+              </a:spcBef>
+              <a:spcAft>
+                <a:spcPts val="0"/>
+              </a:spcAft>
+            </a:pPr>
+            <a:r>
+              <a:rPr sz="1150" b="1" i="0">
+                <a:solidFill>
+                  <a:srgbClr val="5CB85C"/>
+                </a:solidFill>
+                <a:latin typeface="Calibri"/>
+              </a:rPr>
+              <a:t xml:space="preserve">5  Approval reviewer service.  </a:t>
+            </a:r>
+            <a:r>
+              <a:rPr sz="1150" b="0" i="0">
+                <a:solidFill>
+                  <a:srgbClr val="F4F6F8"/>
+                </a:solidFill>
+                <a:latin typeface="Calibri"/>
+              </a:rPr>
+              <a:t>Wrong role, self-approval, and replay all rejected.</a:t>
+            </a:r>
+          </a:p>
+        </p:txBody>
+      </p:sp>
+      <p:sp>
+        <p:nvSpPr>
+          <p:cNvPr id="8" name="RightCard"/>
+          <p:cNvSpPr/>
+          <p:nvPr/>
+        </p:nvSpPr>
+        <p:spPr>
+          <a:xfrm>
+            <a:off x="6126480" y="1691640"/>
+            <a:ext cx="5394960" cy="4023360"/>
+          </a:xfrm>
+          <a:prstGeom prst="roundRect">
+            <a:avLst/>
+          </a:prstGeom>
+          <a:solidFill>
+            <a:srgbClr val="1B242F"/>
+          </a:solidFill>
+          <a:ln w="12700">
+            <a:solidFill>
+              <a:srgbClr val="F5A623"/>
+            </a:solidFill>
+          </a:ln>
+          <a:effectLst/>
+        </p:spPr>
+        <p:style>
+          <a:lnRef idx="1">
+            <a:schemeClr val="accent1"/>
+          </a:lnRef>
+          <a:fillRef idx="3">
+            <a:schemeClr val="accent1"/>
+          </a:fillRef>
+          <a:effectRef idx="2">
+            <a:schemeClr val="accent1"/>
+          </a:effectRef>
+          <a:fontRef idx="minor">
+            <a:schemeClr val="lt1"/>
+          </a:fontRef>
+        </p:style>
+        <p:txBody>
+          <a:bodyPr rtlCol="0" anchor="ctr"/>
+          <a:lstStyle/>
+          <a:p>
+            <a:pPr algn="ctr"/>
+          </a:p>
+        </p:txBody>
+      </p:sp>
+      <p:sp>
+        <p:nvSpPr>
+          <p:cNvPr id="9" name="RightText"/>
+          <p:cNvSpPr txBox="1"/>
+          <p:nvPr/>
+        </p:nvSpPr>
+        <p:spPr>
+          <a:xfrm>
+            <a:off x="6355080" y="1874520"/>
+            <a:ext cx="4937760" cy="3657600"/>
+          </a:xfrm>
+          <a:prstGeom prst="rect">
+            <a:avLst/>
+          </a:prstGeom>
+          <a:noFill/>
+        </p:spPr>
+        <p:txBody>
+          <a:bodyPr wrap="square" anchor="t" lIns="0" rIns="0" tIns="0" bIns="0"/>
+          <a:lstStyle/>
+          <a:p>
+            <a:pPr algn="l">
+              <a:spcBef>
+                <a:spcPts val="0"/>
+              </a:spcBef>
+              <a:spcAft>
+                <a:spcPts val="900"/>
+              </a:spcAft>
+            </a:pPr>
+            <a:r>
+              <a:rPr sz="1450" b="1" i="0">
+                <a:solidFill>
+                  <a:srgbClr val="F5A623"/>
+                </a:solidFill>
+                <a:latin typeface="Cambria"/>
+              </a:rPr>
+              <a:t>Runs 6–9</a:t>
+            </a:r>
+          </a:p>
+          <a:p>
+            <a:pPr algn="l">
+              <a:lnSpc>
+                <a:spcPct val="106000"/>
+              </a:lnSpc>
+              <a:spcBef>
+                <a:spcPts val="0"/>
+              </a:spcBef>
+              <a:spcAft>
+                <a:spcPts val="700"/>
+              </a:spcAft>
+            </a:pPr>
+            <a:r>
+              <a:rPr sz="1150" b="1" i="0">
+                <a:solidFill>
+                  <a:srgbClr val="F5A623"/>
+                </a:solidFill>
+                <a:latin typeface="Calibri"/>
+              </a:rPr>
+              <a:t xml:space="preserve">6  Immutable evidence.  </a:t>
+            </a:r>
+            <a:r>
+              <a:rPr sz="1150" b="0" i="0">
+                <a:solidFill>
+                  <a:srgbClr val="F4F6F8"/>
+                </a:solidFill>
+                <a:latin typeface="Calibri"/>
+              </a:rPr>
+              <a:t>S3 Object Lock retention — locked-object delete denied.</a:t>
+            </a:r>
+          </a:p>
+          <a:p>
+            <a:pPr algn="l">
+              <a:lnSpc>
+                <a:spcPct val="106000"/>
+              </a:lnSpc>
+              <a:spcBef>
+                <a:spcPts val="0"/>
+              </a:spcBef>
+              <a:spcAft>
+                <a:spcPts val="700"/>
+              </a:spcAft>
+            </a:pPr>
+            <a:r>
+              <a:rPr sz="1150" b="1" i="0">
+                <a:solidFill>
+                  <a:srgbClr val="F5A623"/>
+                </a:solidFill>
+                <a:latin typeface="Calibri"/>
+              </a:rPr>
+              <a:t xml:space="preserve">7  Reviewer front door.  </a:t>
+            </a:r>
+            <a:r>
+              <a:rPr sz="1150" b="0" i="0">
+                <a:solidFill>
+                  <a:srgbClr val="F4F6F8"/>
+                </a:solidFill>
+                <a:latin typeface="Calibri"/>
+              </a:rPr>
+              <a:t>API Gateway + Cognito JWT authorizer — 401 unauth; authorized approve → SUCCEEDED.</a:t>
+            </a:r>
+          </a:p>
+          <a:p>
+            <a:pPr algn="l">
+              <a:lnSpc>
+                <a:spcPct val="106000"/>
+              </a:lnSpc>
+              <a:spcBef>
+                <a:spcPts val="0"/>
+              </a:spcBef>
+              <a:spcAft>
+                <a:spcPts val="700"/>
+              </a:spcAft>
+            </a:pPr>
+            <a:r>
+              <a:rPr sz="1150" b="1" i="0">
+                <a:solidFill>
+                  <a:srgbClr val="F5A623"/>
+                </a:solidFill>
+                <a:latin typeface="Calibri"/>
+              </a:rPr>
+              <a:t xml:space="preserve">8  Production components.  </a:t>
+            </a:r>
+            <a:r>
+              <a:rPr sz="1150" b="0" i="0">
+                <a:solidFill>
+                  <a:srgbClr val="F4F6F8"/>
+                </a:solidFill>
+                <a:latin typeface="Calibri"/>
+              </a:rPr>
+              <a:t>KMS-signed manifests + atomic token budgets (no oversell).</a:t>
+            </a:r>
+          </a:p>
+          <a:p>
+            <a:pPr algn="l">
+              <a:lnSpc>
+                <a:spcPct val="106000"/>
+              </a:lnSpc>
+              <a:spcBef>
+                <a:spcPts val="0"/>
+              </a:spcBef>
+              <a:spcAft>
+                <a:spcPts val="0"/>
+              </a:spcAft>
+            </a:pPr>
+            <a:r>
+              <a:rPr sz="1150" b="1" i="0">
+                <a:solidFill>
+                  <a:srgbClr val="F5A623"/>
+                </a:solidFill>
+                <a:latin typeface="Calibri"/>
+              </a:rPr>
+              <a:t xml:space="preserve">9  Governed connector.  </a:t>
+            </a:r>
+            <a:r>
+              <a:rPr sz="1150" b="0" i="0">
+                <a:solidFill>
+                  <a:srgbClr val="F4F6F8"/>
+                </a:solidFill>
+                <a:latin typeface="Calibri"/>
+              </a:rPr>
+              <a:t>Idempotency + saga rollback (auto-compensation).</a:t>
+            </a:r>
+          </a:p>
+        </p:txBody>
+      </p:sp>
+      <p:sp>
+        <p:nvSpPr>
+          <p:cNvPr id="10" name="Caption"/>
+          <p:cNvSpPr txBox="1"/>
+          <p:nvPr/>
+        </p:nvSpPr>
+        <p:spPr>
+          <a:xfrm>
+            <a:off x="640080" y="5836920"/>
+            <a:ext cx="9783960" cy="548640"/>
+          </a:xfrm>
+          <a:prstGeom prst="rect">
+            <a:avLst/>
+          </a:prstGeom>
+          <a:noFill/>
+        </p:spPr>
+        <p:txBody>
+          <a:bodyPr wrap="square" anchor="t" lIns="0" rIns="0" tIns="0" bIns="0"/>
+          <a:lstStyle/>
+          <a:p>
+            <a:pPr algn="l">
+              <a:lnSpc>
+                <a:spcPct val="108000"/>
+              </a:lnSpc>
+              <a:spcBef>
+                <a:spcPts val="0"/>
+              </a:spcBef>
+              <a:spcAft>
+                <a:spcPts val="0"/>
+              </a:spcAft>
+            </a:pPr>
+            <a:r>
+              <a:rPr sz="1000" b="0" i="0">
+                <a:solidFill>
+                  <a:srgbClr val="738292"/>
+                </a:solidFill>
+                <a:latin typeface="Calibri"/>
+              </a:rPr>
+              <a:t>Reproducible from infra/ (CloudFormation) and infra/terraform/. This is a live-validated reference platform, not yet an ATO’d product. Evidence: DEPLOYED-AND-VALIDATED.md.</a:t>
+            </a:r>
+          </a:p>
+        </p:txBody>
+      </p:sp>
+      <p:sp>
+        <p:nvSpPr>
+          <p:cNvPr id="11" name="PageNum"/>
+          <p:cNvSpPr txBox="1"/>
+          <p:nvPr/>
+        </p:nvSpPr>
+        <p:spPr>
+          <a:xfrm>
+            <a:off x="10607040" y="6455664"/>
+            <a:ext cx="1371600" cy="274320"/>
+          </a:xfrm>
+          <a:prstGeom prst="rect">
+            <a:avLst/>
+          </a:prstGeom>
+          <a:noFill/>
+        </p:spPr>
+        <p:txBody>
+          <a:bodyPr wrap="square" anchor="t" lIns="0" rIns="0" tIns="0" bIns="0">
+            <a:spAutoFit/>
+          </a:bodyPr>
+          <a:lstStyle/>
+          <a:p>
+            <a:pPr algn="r">
+              <a:spcBef>
+                <a:spcPts val="0"/>
+              </a:spcBef>
+              <a:spcAft>
+                <a:spcPts val="0"/>
+              </a:spcAft>
+            </a:pPr>
+            <a:r>
+              <a:rPr sz="900" b="0" i="0">
+                <a:solidFill>
+                  <a:srgbClr val="738292"/>
+                </a:solidFill>
+                <a:latin typeface="Calibri"/>
+              </a:rPr>
+              <a:t>Aegis  ·  16</a:t>
             </a:r>
           </a:p>
         </p:txBody>
@@ -22457,7 +23185,7 @@
                 </a:solidFill>
                 <a:latin typeface="Calibri"/>
               </a:rPr>
-              <a:t>✕  </a:t>
+              <a:t xml:space="preserve">✕  </a:t>
             </a:r>
             <a:r>
               <a:rPr sz="1450" b="0" i="0">
@@ -22488,7 +23216,7 @@
                 </a:solidFill>
                 <a:latin typeface="Calibri"/>
               </a:rPr>
-              <a:t>✕  </a:t>
+              <a:t xml:space="preserve">✕  </a:t>
             </a:r>
             <a:r>
               <a:rPr sz="1450" b="0" i="0">
@@ -22519,7 +23247,7 @@
                 </a:solidFill>
                 <a:latin typeface="Calibri"/>
               </a:rPr>
-              <a:t>✕  </a:t>
+              <a:t xml:space="preserve">✕  </a:t>
             </a:r>
             <a:r>
               <a:rPr sz="1450" b="0" i="0">
@@ -22550,7 +23278,7 @@
                 </a:solidFill>
                 <a:latin typeface="Calibri"/>
               </a:rPr>
-              <a:t>✕  </a:t>
+              <a:t xml:space="preserve">✕  </a:t>
             </a:r>
             <a:r>
               <a:rPr sz="1450" b="0" i="0">
@@ -22669,7 +23397,7 @@
                 </a:solidFill>
                 <a:latin typeface="Calibri"/>
               </a:rPr>
-              <a:t>✓  </a:t>
+              <a:t xml:space="preserve">✓  </a:t>
             </a:r>
             <a:r>
               <a:rPr sz="1450" b="0" i="0">
@@ -22700,7 +23428,7 @@
                 </a:solidFill>
                 <a:latin typeface="Calibri"/>
               </a:rPr>
-              <a:t>✓  </a:t>
+              <a:t xml:space="preserve">✓  </a:t>
             </a:r>
             <a:r>
               <a:rPr sz="1450" b="0" i="0">
@@ -22731,7 +23459,7 @@
                 </a:solidFill>
                 <a:latin typeface="Calibri"/>
               </a:rPr>
-              <a:t>✓  </a:t>
+              <a:t xml:space="preserve">✓  </a:t>
             </a:r>
             <a:r>
               <a:rPr sz="1450" b="0" i="0">
@@ -22762,7 +23490,7 @@
                 </a:solidFill>
                 <a:latin typeface="Calibri"/>
               </a:rPr>
-              <a:t>✓  </a:t>
+              <a:t xml:space="preserve">✓  </a:t>
             </a:r>
             <a:r>
               <a:rPr sz="1450" b="0" i="0">
@@ -25064,7 +25792,7 @@
                 </a:solidFill>
                 <a:latin typeface="Calibri"/>
               </a:rPr>
-              <a:t>Edge:  </a:t>
+              <a:t xml:space="preserve">Edge:  </a:t>
             </a:r>
             <a:r>
               <a:rPr sz="1150" b="0" i="0">
@@ -25112,7 +25840,7 @@
                 </a:solidFill>
                 <a:latin typeface="Calibri"/>
               </a:rPr>
-              <a:t>Identity:  </a:t>
+              <a:t xml:space="preserve">Identity:  </a:t>
             </a:r>
             <a:r>
               <a:rPr sz="1150" b="0" i="0">
@@ -25160,7 +25888,7 @@
                 </a:solidFill>
                 <a:latin typeface="Calibri"/>
               </a:rPr>
-              <a:t>Control plane:  </a:t>
+              <a:t xml:space="preserve">Control plane:  </a:t>
             </a:r>
             <a:r>
               <a:rPr sz="1150" b="0" i="0">
@@ -25208,7 +25936,7 @@
                 </a:solidFill>
                 <a:latin typeface="Calibri"/>
               </a:rPr>
-              <a:t>Model gateway:  </a:t>
+              <a:t xml:space="preserve">Model gateway:  </a:t>
             </a:r>
             <a:r>
               <a:rPr sz="1150" b="0" i="0">
@@ -25256,7 +25984,7 @@
                 </a:solidFill>
                 <a:latin typeface="Calibri"/>
               </a:rPr>
-              <a:t>Data / evidence:  </a:t>
+              <a:t xml:space="preserve">Data / evidence:  </a:t>
             </a:r>
             <a:r>
               <a:rPr sz="1150" b="0" i="0">
@@ -25304,7 +26032,7 @@
                 </a:solidFill>
                 <a:latin typeface="Calibri"/>
               </a:rPr>
-              <a:t>FinOps / obs:  </a:t>
+              <a:t xml:space="preserve">FinOps / obs:  </a:t>
             </a:r>
             <a:r>
               <a:rPr sz="1150" b="0" i="0">
@@ -25391,7 +26119,7 @@
                 </a:solidFill>
                 <a:latin typeface="Calibri"/>
               </a:rPr>
-              <a:t>Multi-account landing zone (Control Tower):  </a:t>
+              <a:t xml:space="preserve">Multi-account landing zone (Control Tower):  </a:t>
             </a:r>
             <a:r>
               <a:rPr sz="1150" b="0" i="0">

</xml_diff>

<commit_message>
feat: Run 10 MCP gateway, account-ID redaction, evidence pack, diagrams
Add the live-validated MCP JSON-RPC gateway (mcp-gateway.yaml), sanitized
clean-account acceptance evidence, architecture diagrams, capability
maturity matrix in README, and redact the AWS validation account ID
across all docs. Remove stale leadership brief and original project
brief. Update terminology to "private-connectivity inference" and
bump run count to ten throughout.

Co-Authored-By: Claude Opus 4.6 (1M context) <noreply@anthropic.com>
</commit_message>
<xml_diff>
--- a/Aegis-Master-Deck.pptx
+++ b/Aegis-Master-Deck.pptx
@@ -5132,7 +5132,7 @@
           <a:noFill/>
           <a:ln w="31750">
             <a:solidFill>
-              <a:srgbClr val="F5A623"/>
+              <a:srgbClr val="FF9900"/>
             </a:solidFill>
           </a:ln>
           <a:effectLst/>
@@ -5218,7 +5218,7 @@
             <a:avLst/>
           </a:prstGeom>
           <a:solidFill>
-            <a:srgbClr val="F5A623"/>
+            <a:srgbClr val="FF9900"/>
           </a:solidFill>
           <a:ln>
             <a:noFill/>
@@ -5353,7 +5353,7 @@
             <a:r>
               <a:rPr sz="2200" b="0" i="1">
                 <a:solidFill>
-                  <a:srgbClr val="F5A623"/>
+                  <a:srgbClr val="FF9900"/>
                 </a:solidFill>
                 <a:latin typeface="Cambria"/>
               </a:rPr>
@@ -5589,7 +5589,7 @@
             <a:r>
               <a:rPr sz="3300" b="1" i="0">
                 <a:solidFill>
-                  <a:srgbClr val="1B242F"/>
+                  <a:srgbClr val="232F3E"/>
                 </a:solidFill>
                 <a:latin typeface="Cambria"/>
               </a:rPr>
@@ -5719,7 +5719,7 @@
             <a:r>
               <a:rPr sz="1250" b="1" i="0">
                 <a:solidFill>
-                  <a:srgbClr val="1B242F"/>
+                  <a:srgbClr val="232F3E"/>
                 </a:solidFill>
                 <a:latin typeface="Calibri"/>
               </a:rPr>
@@ -5849,7 +5849,7 @@
             <a:r>
               <a:rPr sz="1250" b="1" i="0">
                 <a:solidFill>
-                  <a:srgbClr val="1B242F"/>
+                  <a:srgbClr val="232F3E"/>
                 </a:solidFill>
                 <a:latin typeface="Calibri"/>
               </a:rPr>
@@ -5873,7 +5873,7 @@
             <a:avLst/>
           </a:prstGeom>
           <a:solidFill>
-            <a:srgbClr val="1B242F"/>
+            <a:srgbClr val="232F3E"/>
           </a:solidFill>
           <a:ln>
             <a:noFill/>
@@ -5950,7 +5950,7 @@
             <a:r>
               <a:rPr sz="1250" b="1" i="0">
                 <a:solidFill>
-                  <a:srgbClr val="F5A623"/>
+                  <a:srgbClr val="FF9900"/>
                 </a:solidFill>
                 <a:latin typeface="Calibri"/>
               </a:rPr>
@@ -5968,7 +5968,7 @@
             <a:r>
               <a:rPr sz="1250" b="1" i="0">
                 <a:solidFill>
-                  <a:srgbClr val="F5A623"/>
+                  <a:srgbClr val="FF9900"/>
                 </a:solidFill>
                 <a:latin typeface="Calibri"/>
               </a:rPr>
@@ -6022,7 +6022,7 @@
             <a:r>
               <a:rPr sz="1250" b="1" i="0">
                 <a:solidFill>
-                  <a:srgbClr val="F5A623"/>
+                  <a:srgbClr val="FF9900"/>
                 </a:solidFill>
                 <a:latin typeface="Calibri"/>
               </a:rPr>
@@ -6213,7 +6213,7 @@
             <a:r>
               <a:rPr sz="1250" b="1" i="0">
                 <a:solidFill>
-                  <a:srgbClr val="F5A623"/>
+                  <a:srgbClr val="FF9900"/>
                 </a:solidFill>
                 <a:latin typeface="Calibri"/>
               </a:rPr>
@@ -6410,7 +6410,7 @@
             <a:r>
               <a:rPr sz="1150" b="0" i="0">
                 <a:solidFill>
-                  <a:srgbClr val="F5A623"/>
+                  <a:srgbClr val="FF9900"/>
                 </a:solidFill>
                 <a:latin typeface="Consolas"/>
               </a:rPr>
@@ -6471,7 +6471,7 @@
             <a:r>
               <a:rPr sz="1300" b="1" i="0">
                 <a:solidFill>
-                  <a:srgbClr val="F5A623"/>
+                  <a:srgbClr val="FF9900"/>
                 </a:solidFill>
                 <a:latin typeface="Cambria"/>
               </a:rPr>
@@ -6607,11 +6607,11 @@
             <a:avLst/>
           </a:prstGeom>
           <a:solidFill>
-            <a:srgbClr val="1B242F"/>
+            <a:srgbClr val="232F3E"/>
           </a:solidFill>
           <a:ln w="12700">
             <a:solidFill>
-              <a:srgbClr val="F5A623"/>
+              <a:srgbClr val="FF9900"/>
             </a:solidFill>
           </a:ln>
           <a:effectLst/>
@@ -6671,7 +6671,7 @@
             <a:r>
               <a:rPr sz="1500" b="1" i="0">
                 <a:solidFill>
-                  <a:srgbClr val="F5A623"/>
+                  <a:srgbClr val="FF9900"/>
                 </a:solidFill>
                 <a:latin typeface="Cambria"/>
               </a:rPr>
@@ -6693,7 +6693,7 @@
             <a:r>
               <a:rPr sz="1250" b="1" i="0">
                 <a:solidFill>
-                  <a:srgbClr val="F5A623"/>
+                  <a:srgbClr val="FF9900"/>
                 </a:solidFill>
                 <a:latin typeface="Calibri"/>
               </a:rPr>
@@ -6724,7 +6724,7 @@
             <a:r>
               <a:rPr sz="1250" b="1" i="0">
                 <a:solidFill>
-                  <a:srgbClr val="F5A623"/>
+                  <a:srgbClr val="FF9900"/>
                 </a:solidFill>
                 <a:latin typeface="Calibri"/>
               </a:rPr>
@@ -6755,7 +6755,7 @@
             <a:r>
               <a:rPr sz="1250" b="1" i="0">
                 <a:solidFill>
-                  <a:srgbClr val="F5A623"/>
+                  <a:srgbClr val="FF9900"/>
                 </a:solidFill>
                 <a:latin typeface="Calibri"/>
               </a:rPr>
@@ -6786,7 +6786,7 @@
             <a:r>
               <a:rPr sz="1250" b="1" i="0">
                 <a:solidFill>
-                  <a:srgbClr val="F5A623"/>
+                  <a:srgbClr val="FF9900"/>
                 </a:solidFill>
                 <a:latin typeface="Calibri"/>
               </a:rPr>
@@ -6817,7 +6817,7 @@
             <a:r>
               <a:rPr sz="1250" b="1" i="0">
                 <a:solidFill>
-                  <a:srgbClr val="F5A623"/>
+                  <a:srgbClr val="FF9900"/>
                 </a:solidFill>
                 <a:latin typeface="Calibri"/>
               </a:rPr>
@@ -6848,7 +6848,7 @@
             <a:r>
               <a:rPr sz="1250" b="1" i="0">
                 <a:solidFill>
-                  <a:srgbClr val="F5A623"/>
+                  <a:srgbClr val="FF9900"/>
                 </a:solidFill>
                 <a:latin typeface="Calibri"/>
               </a:rPr>
@@ -6879,7 +6879,7 @@
             <a:r>
               <a:rPr sz="1250" b="1" i="0">
                 <a:solidFill>
-                  <a:srgbClr val="F5A623"/>
+                  <a:srgbClr val="FF9900"/>
                 </a:solidFill>
                 <a:latin typeface="Calibri"/>
               </a:rPr>
@@ -6910,7 +6910,7 @@
             <a:r>
               <a:rPr sz="1250" b="1" i="0">
                 <a:solidFill>
-                  <a:srgbClr val="F5A623"/>
+                  <a:srgbClr val="FF9900"/>
                 </a:solidFill>
                 <a:latin typeface="Calibri"/>
               </a:rPr>
@@ -6941,7 +6941,7 @@
             <a:r>
               <a:rPr sz="1250" b="1" i="0">
                 <a:solidFill>
-                  <a:srgbClr val="F5A623"/>
+                  <a:srgbClr val="FF9900"/>
                 </a:solidFill>
                 <a:latin typeface="Calibri"/>
               </a:rPr>
@@ -7138,7 +7138,7 @@
             <a:r>
               <a:rPr sz="1250" b="1" i="0">
                 <a:solidFill>
-                  <a:srgbClr val="F5A623"/>
+                  <a:srgbClr val="FF9900"/>
                 </a:solidFill>
                 <a:latin typeface="Calibri"/>
               </a:rPr>
@@ -7207,7 +7207,7 @@
             <a:avLst/>
           </a:prstGeom>
           <a:solidFill>
-            <a:srgbClr val="1B242F"/>
+            <a:srgbClr val="232F3E"/>
           </a:solidFill>
           <a:ln>
             <a:noFill/>
@@ -7251,7 +7251,7 @@
             <a:avLst/>
           </a:prstGeom>
           <a:solidFill>
-            <a:srgbClr val="F5A623"/>
+            <a:srgbClr val="FF9900"/>
           </a:solidFill>
           <a:ln>
             <a:noFill/>
@@ -7325,7 +7325,7 @@
             <a:r>
               <a:rPr sz="1600" b="1" i="0">
                 <a:solidFill>
-                  <a:srgbClr val="F5A623"/>
+                  <a:srgbClr val="FF9900"/>
                 </a:solidFill>
                 <a:latin typeface="Cambria"/>
               </a:rPr>
@@ -7390,7 +7390,7 @@
             <a:avLst/>
           </a:prstGeom>
           <a:solidFill>
-            <a:srgbClr val="F5A623"/>
+            <a:srgbClr val="FF9900"/>
           </a:solidFill>
           <a:ln>
             <a:noFill/>
@@ -7434,7 +7434,7 @@
             <a:avLst/>
           </a:prstGeom>
           <a:solidFill>
-            <a:srgbClr val="1B242F"/>
+            <a:srgbClr val="232F3E"/>
           </a:solidFill>
           <a:ln>
             <a:noFill/>
@@ -7617,7 +7617,7 @@
             <a:avLst/>
           </a:prstGeom>
           <a:solidFill>
-            <a:srgbClr val="F5A623"/>
+            <a:srgbClr val="FF9900"/>
           </a:solidFill>
           <a:ln>
             <a:noFill/>
@@ -7661,7 +7661,7 @@
             <a:avLst/>
           </a:prstGeom>
           <a:solidFill>
-            <a:srgbClr val="1B242F"/>
+            <a:srgbClr val="232F3E"/>
           </a:solidFill>
           <a:ln>
             <a:noFill/>
@@ -7865,7 +7865,7 @@
             <a:r>
               <a:rPr sz="1350" b="0" i="1">
                 <a:solidFill>
-                  <a:srgbClr val="F5A623"/>
+                  <a:srgbClr val="FF9900"/>
                 </a:solidFill>
                 <a:latin typeface="Calibri"/>
               </a:rPr>
@@ -8011,7 +8011,7 @@
             <a:r>
               <a:rPr sz="1250" b="1" i="0">
                 <a:solidFill>
-                  <a:srgbClr val="F5A623"/>
+                  <a:srgbClr val="FF9900"/>
                 </a:solidFill>
                 <a:latin typeface="Calibri"/>
               </a:rPr>
@@ -8125,7 +8125,7 @@
             <a:avLst/>
           </a:prstGeom>
           <a:solidFill>
-            <a:srgbClr val="1B242F"/>
+            <a:srgbClr val="232F3E"/>
           </a:solidFill>
           <a:ln>
             <a:noFill/>
@@ -8214,7 +8214,7 @@
             <a:avLst/>
           </a:prstGeom>
           <a:solidFill>
-            <a:srgbClr val="1B242F"/>
+            <a:srgbClr val="232F3E"/>
           </a:solidFill>
           <a:ln>
             <a:noFill/>
@@ -8394,7 +8394,7 @@
             <a:avLst/>
           </a:prstGeom>
           <a:solidFill>
-            <a:srgbClr val="1B242F"/>
+            <a:srgbClr val="232F3E"/>
           </a:solidFill>
           <a:ln>
             <a:noFill/>
@@ -8483,7 +8483,7 @@
             <a:avLst/>
           </a:prstGeom>
           <a:solidFill>
-            <a:srgbClr val="1B242F"/>
+            <a:srgbClr val="232F3E"/>
           </a:solidFill>
           <a:ln>
             <a:noFill/>
@@ -8548,7 +8548,7 @@
             <a:r>
               <a:rPr sz="1050" b="1" i="0">
                 <a:solidFill>
-                  <a:srgbClr val="F5A623"/>
+                  <a:srgbClr val="FF9900"/>
                 </a:solidFill>
                 <a:latin typeface="Calibri"/>
               </a:rPr>
@@ -8663,7 +8663,7 @@
             <a:avLst/>
           </a:prstGeom>
           <a:solidFill>
-            <a:srgbClr val="1B242F"/>
+            <a:srgbClr val="232F3E"/>
           </a:solidFill>
           <a:ln>
             <a:noFill/>
@@ -8752,7 +8752,7 @@
             <a:avLst/>
           </a:prstGeom>
           <a:solidFill>
-            <a:srgbClr val="1B242F"/>
+            <a:srgbClr val="232F3E"/>
           </a:solidFill>
           <a:ln>
             <a:noFill/>
@@ -8841,7 +8841,7 @@
             <a:avLst/>
           </a:prstGeom>
           <a:solidFill>
-            <a:srgbClr val="1B242F"/>
+            <a:srgbClr val="232F3E"/>
           </a:solidFill>
           <a:ln>
             <a:noFill/>
@@ -9561,7 +9561,7 @@
             <a:r>
               <a:rPr sz="2900" b="1" i="0">
                 <a:solidFill>
-                  <a:srgbClr val="1B242F"/>
+                  <a:srgbClr val="232F3E"/>
                 </a:solidFill>
                 <a:latin typeface="Cambria"/>
               </a:rPr>
@@ -9678,7 +9678,7 @@
             <a:r>
               <a:rPr sz="1150" b="0" i="0">
                 <a:solidFill>
-                  <a:srgbClr val="1B242F"/>
+                  <a:srgbClr val="232F3E"/>
                 </a:solidFill>
                 <a:latin typeface="Calibri"/>
               </a:rPr>
@@ -9709,7 +9709,7 @@
             <a:r>
               <a:rPr sz="1150" b="0" i="0">
                 <a:solidFill>
-                  <a:srgbClr val="1B242F"/>
+                  <a:srgbClr val="232F3E"/>
                 </a:solidFill>
                 <a:latin typeface="Calibri"/>
               </a:rPr>
@@ -9740,7 +9740,7 @@
             <a:r>
               <a:rPr sz="1150" b="0" i="0">
                 <a:solidFill>
-                  <a:srgbClr val="1B242F"/>
+                  <a:srgbClr val="232F3E"/>
                 </a:solidFill>
                 <a:latin typeface="Calibri"/>
               </a:rPr>
@@ -9771,7 +9771,7 @@
             <a:r>
               <a:rPr sz="1150" b="0" i="0">
                 <a:solidFill>
-                  <a:srgbClr val="1B242F"/>
+                  <a:srgbClr val="232F3E"/>
                 </a:solidFill>
                 <a:latin typeface="Calibri"/>
               </a:rPr>
@@ -9802,7 +9802,7 @@
             <a:r>
               <a:rPr sz="1150" b="0" i="0">
                 <a:solidFill>
-                  <a:srgbClr val="1B242F"/>
+                  <a:srgbClr val="232F3E"/>
                 </a:solidFill>
                 <a:latin typeface="Calibri"/>
               </a:rPr>
@@ -9833,7 +9833,7 @@
             <a:r>
               <a:rPr sz="1150" b="0" i="0">
                 <a:solidFill>
-                  <a:srgbClr val="1B242F"/>
+                  <a:srgbClr val="232F3E"/>
                 </a:solidFill>
                 <a:latin typeface="Calibri"/>
               </a:rPr>
@@ -9864,7 +9864,7 @@
             <a:r>
               <a:rPr sz="1150" b="0" i="0">
                 <a:solidFill>
-                  <a:srgbClr val="1B242F"/>
+                  <a:srgbClr val="232F3E"/>
                 </a:solidFill>
                 <a:latin typeface="Calibri"/>
               </a:rPr>
@@ -9895,7 +9895,7 @@
             <a:r>
               <a:rPr sz="1150" b="0" i="0">
                 <a:solidFill>
-                  <a:srgbClr val="1B242F"/>
+                  <a:srgbClr val="232F3E"/>
                 </a:solidFill>
                 <a:latin typeface="Calibri"/>
               </a:rPr>
@@ -9919,7 +9919,7 @@
             <a:avLst/>
           </a:prstGeom>
           <a:solidFill>
-            <a:srgbClr val="1B242F"/>
+            <a:srgbClr val="232F3E"/>
           </a:solidFill>
           <a:ln>
             <a:noFill/>
@@ -9981,7 +9981,7 @@
             <a:r>
               <a:rPr sz="1500" b="1" i="0">
                 <a:solidFill>
-                  <a:srgbClr val="F5A623"/>
+                  <a:srgbClr val="FF9900"/>
                 </a:solidFill>
                 <a:latin typeface="Cambria"/>
               </a:rPr>
@@ -10003,7 +10003,7 @@
             <a:r>
               <a:rPr sz="1150" b="1" i="0">
                 <a:solidFill>
-                  <a:srgbClr val="F5A623"/>
+                  <a:srgbClr val="FF9900"/>
                 </a:solidFill>
                 <a:latin typeface="Calibri"/>
               </a:rPr>
@@ -10034,7 +10034,7 @@
             <a:r>
               <a:rPr sz="1150" b="1" i="0">
                 <a:solidFill>
-                  <a:srgbClr val="F5A623"/>
+                  <a:srgbClr val="FF9900"/>
                 </a:solidFill>
                 <a:latin typeface="Calibri"/>
               </a:rPr>
@@ -10065,7 +10065,7 @@
             <a:r>
               <a:rPr sz="1150" b="1" i="0">
                 <a:solidFill>
-                  <a:srgbClr val="F5A623"/>
+                  <a:srgbClr val="FF9900"/>
                 </a:solidFill>
                 <a:latin typeface="Calibri"/>
               </a:rPr>
@@ -10096,7 +10096,7 @@
             <a:r>
               <a:rPr sz="1150" b="1" i="0">
                 <a:solidFill>
-                  <a:srgbClr val="F5A623"/>
+                  <a:srgbClr val="FF9900"/>
                 </a:solidFill>
                 <a:latin typeface="Calibri"/>
               </a:rPr>
@@ -10127,7 +10127,7 @@
             <a:r>
               <a:rPr sz="1150" b="1" i="0">
                 <a:solidFill>
-                  <a:srgbClr val="F5A623"/>
+                  <a:srgbClr val="FF9900"/>
                 </a:solidFill>
                 <a:latin typeface="Calibri"/>
               </a:rPr>
@@ -10158,7 +10158,7 @@
             <a:r>
               <a:rPr sz="1150" b="1" i="0">
                 <a:solidFill>
-                  <a:srgbClr val="F5A623"/>
+                  <a:srgbClr val="FF9900"/>
                 </a:solidFill>
                 <a:latin typeface="Calibri"/>
               </a:rPr>
@@ -10189,7 +10189,7 @@
             <a:r>
               <a:rPr sz="1150" b="1" i="0">
                 <a:solidFill>
-                  <a:srgbClr val="F5A623"/>
+                  <a:srgbClr val="FF9900"/>
                 </a:solidFill>
                 <a:latin typeface="Calibri"/>
               </a:rPr>
@@ -10344,7 +10344,7 @@
             <a:r>
               <a:rPr sz="1250" b="1" i="0">
                 <a:solidFill>
-                  <a:srgbClr val="F5A623"/>
+                  <a:srgbClr val="FF9900"/>
                 </a:solidFill>
                 <a:latin typeface="Calibri"/>
               </a:rPr>
@@ -10413,7 +10413,7 @@
             <a:avLst/>
           </a:prstGeom>
           <a:solidFill>
-            <a:srgbClr val="1B242F"/>
+            <a:srgbClr val="232F3E"/>
           </a:solidFill>
           <a:ln w="12700">
             <a:solidFill>
@@ -10749,11 +10749,11 @@
             <a:avLst/>
           </a:prstGeom>
           <a:solidFill>
-            <a:srgbClr val="1B242F"/>
+            <a:srgbClr val="232F3E"/>
           </a:solidFill>
           <a:ln w="12700">
             <a:solidFill>
-              <a:srgbClr val="F5A623"/>
+              <a:srgbClr val="FF9900"/>
             </a:solidFill>
           </a:ln>
           <a:effectLst/>
@@ -10813,7 +10813,7 @@
             <a:r>
               <a:rPr sz="1450" b="1" i="0">
                 <a:solidFill>
-                  <a:srgbClr val="F5A623"/>
+                  <a:srgbClr val="FF9900"/>
                 </a:solidFill>
                 <a:latin typeface="Cambria"/>
               </a:rPr>
@@ -10835,7 +10835,7 @@
             <a:r>
               <a:rPr sz="1150" b="1" i="0">
                 <a:solidFill>
-                  <a:srgbClr val="F5A623"/>
+                  <a:srgbClr val="FF9900"/>
                 </a:solidFill>
                 <a:latin typeface="Calibri"/>
               </a:rPr>
@@ -10866,7 +10866,7 @@
             <a:r>
               <a:rPr sz="1150" b="1" i="0">
                 <a:solidFill>
-                  <a:srgbClr val="F5A623"/>
+                  <a:srgbClr val="FF9900"/>
                 </a:solidFill>
                 <a:latin typeface="Calibri"/>
               </a:rPr>
@@ -10897,7 +10897,7 @@
             <a:r>
               <a:rPr sz="1150" b="1" i="0">
                 <a:solidFill>
-                  <a:srgbClr val="F5A623"/>
+                  <a:srgbClr val="FF9900"/>
                 </a:solidFill>
                 <a:latin typeface="Calibri"/>
               </a:rPr>
@@ -10928,7 +10928,7 @@
             <a:r>
               <a:rPr sz="1150" b="1" i="0">
                 <a:solidFill>
-                  <a:srgbClr val="F5A623"/>
+                  <a:srgbClr val="FF9900"/>
                 </a:solidFill>
                 <a:latin typeface="Calibri"/>
               </a:rPr>
@@ -10959,7 +10959,7 @@
             <a:r>
               <a:rPr sz="1150" b="1" i="0">
                 <a:solidFill>
-                  <a:srgbClr val="F5A623"/>
+                  <a:srgbClr val="FF9900"/>
                 </a:solidFill>
                 <a:latin typeface="Calibri"/>
               </a:rPr>
@@ -10990,7 +10990,7 @@
             <a:r>
               <a:rPr sz="1150" b="1" i="0">
                 <a:solidFill>
-                  <a:srgbClr val="F5A623"/>
+                  <a:srgbClr val="FF9900"/>
                 </a:solidFill>
                 <a:latin typeface="Calibri"/>
               </a:rPr>
@@ -11021,7 +11021,7 @@
             <a:r>
               <a:rPr sz="1150" b="1" i="0">
                 <a:solidFill>
-                  <a:srgbClr val="F5A623"/>
+                  <a:srgbClr val="FF9900"/>
                 </a:solidFill>
                 <a:latin typeface="Calibri"/>
               </a:rPr>
@@ -11052,7 +11052,7 @@
             <a:r>
               <a:rPr sz="1150" b="1" i="0">
                 <a:solidFill>
-                  <a:srgbClr val="F5A623"/>
+                  <a:srgbClr val="FF9900"/>
                 </a:solidFill>
                 <a:latin typeface="Calibri"/>
               </a:rPr>
@@ -11139,7 +11139,7 @@
             <a:r>
               <a:rPr sz="1400" b="1" i="0">
                 <a:solidFill>
-                  <a:srgbClr val="F5A623"/>
+                  <a:srgbClr val="FF9900"/>
                 </a:solidFill>
                 <a:latin typeface="Cambria"/>
               </a:rPr>
@@ -11338,7 +11338,7 @@
             <a:r>
               <a:rPr sz="1250" b="1" i="0">
                 <a:solidFill>
-                  <a:srgbClr val="F5A623"/>
+                  <a:srgbClr val="FF9900"/>
                 </a:solidFill>
                 <a:latin typeface="Calibri"/>
               </a:rPr>
@@ -11452,7 +11452,7 @@
             <a:avLst/>
           </a:prstGeom>
           <a:solidFill>
-            <a:srgbClr val="F5A623"/>
+            <a:srgbClr val="FF9900"/>
           </a:solidFill>
           <a:ln>
             <a:noFill/>
@@ -11520,7 +11520,7 @@
             <a:r>
               <a:rPr sz="1500" b="1" i="0">
                 <a:solidFill>
-                  <a:srgbClr val="F5A623"/>
+                  <a:srgbClr val="FF9900"/>
                 </a:solidFill>
                 <a:latin typeface="Cambria"/>
               </a:rPr>
@@ -11553,7 +11553,7 @@
             <a:avLst/>
           </a:prstGeom>
           <a:solidFill>
-            <a:srgbClr val="F5A623"/>
+            <a:srgbClr val="FF9900"/>
           </a:solidFill>
           <a:ln>
             <a:noFill/>
@@ -11621,7 +11621,7 @@
             <a:r>
               <a:rPr sz="1500" b="1" i="0">
                 <a:solidFill>
-                  <a:srgbClr val="F5A623"/>
+                  <a:srgbClr val="FF9900"/>
                 </a:solidFill>
                 <a:latin typeface="Cambria"/>
               </a:rPr>
@@ -11654,7 +11654,7 @@
             <a:avLst/>
           </a:prstGeom>
           <a:solidFill>
-            <a:srgbClr val="F5A623"/>
+            <a:srgbClr val="FF9900"/>
           </a:solidFill>
           <a:ln>
             <a:noFill/>
@@ -11722,7 +11722,7 @@
             <a:r>
               <a:rPr sz="1500" b="1" i="0">
                 <a:solidFill>
-                  <a:srgbClr val="F5A623"/>
+                  <a:srgbClr val="FF9900"/>
                 </a:solidFill>
                 <a:latin typeface="Cambria"/>
               </a:rPr>
@@ -11755,7 +11755,7 @@
             <a:avLst/>
           </a:prstGeom>
           <a:solidFill>
-            <a:srgbClr val="F5A623"/>
+            <a:srgbClr val="FF9900"/>
           </a:solidFill>
           <a:ln>
             <a:noFill/>
@@ -11823,7 +11823,7 @@
             <a:r>
               <a:rPr sz="1500" b="1" i="0">
                 <a:solidFill>
-                  <a:srgbClr val="F5A623"/>
+                  <a:srgbClr val="FF9900"/>
                 </a:solidFill>
                 <a:latin typeface="Cambria"/>
               </a:rPr>
@@ -11856,7 +11856,7 @@
             <a:avLst/>
           </a:prstGeom>
           <a:solidFill>
-            <a:srgbClr val="F5A623"/>
+            <a:srgbClr val="FF9900"/>
           </a:solidFill>
           <a:ln>
             <a:noFill/>
@@ -12049,7 +12049,7 @@
             <a:avLst/>
           </a:prstGeom>
           <a:solidFill>
-            <a:srgbClr val="F5A623"/>
+            <a:srgbClr val="FF9900"/>
           </a:solidFill>
           <a:ln>
             <a:noFill/>
@@ -12162,7 +12162,7 @@
             <a:r>
               <a:rPr sz="2200" b="0" i="1">
                 <a:solidFill>
-                  <a:srgbClr val="F5A623"/>
+                  <a:srgbClr val="FF9900"/>
                 </a:solidFill>
                 <a:latin typeface="Cambria"/>
               </a:rPr>
@@ -12372,7 +12372,7 @@
             <a:r>
               <a:rPr sz="3300" b="1" i="0">
                 <a:solidFill>
-                  <a:srgbClr val="1B242F"/>
+                  <a:srgbClr val="232F3E"/>
                 </a:solidFill>
                 <a:latin typeface="Cambria"/>
               </a:rPr>
@@ -12483,7 +12483,7 @@
             <a:r>
               <a:rPr sz="1250" b="0" i="0">
                 <a:solidFill>
-                  <a:srgbClr val="1B242F"/>
+                  <a:srgbClr val="232F3E"/>
                 </a:solidFill>
                 <a:latin typeface="Calibri"/>
               </a:rPr>
@@ -12594,7 +12594,7 @@
             <a:r>
               <a:rPr sz="1250" b="0" i="0">
                 <a:solidFill>
-                  <a:srgbClr val="1B242F"/>
+                  <a:srgbClr val="232F3E"/>
                 </a:solidFill>
                 <a:latin typeface="Calibri"/>
               </a:rPr>
@@ -12705,7 +12705,7 @@
             <a:r>
               <a:rPr sz="1250" b="0" i="0">
                 <a:solidFill>
-                  <a:srgbClr val="1B242F"/>
+                  <a:srgbClr val="232F3E"/>
                 </a:solidFill>
                 <a:latin typeface="Calibri"/>
               </a:rPr>
@@ -12816,7 +12816,7 @@
             <a:r>
               <a:rPr sz="1250" b="0" i="0">
                 <a:solidFill>
-                  <a:srgbClr val="1B242F"/>
+                  <a:srgbClr val="232F3E"/>
                 </a:solidFill>
                 <a:latin typeface="Calibri"/>
               </a:rPr>
@@ -12962,7 +12962,7 @@
             <a:r>
               <a:rPr sz="1250" b="1" i="0">
                 <a:solidFill>
-                  <a:srgbClr val="F5A623"/>
+                  <a:srgbClr val="FF9900"/>
                 </a:solidFill>
                 <a:latin typeface="Calibri"/>
               </a:rPr>
@@ -13052,7 +13052,7 @@
             <a:r>
               <a:rPr sz="950" b="1" i="0">
                 <a:solidFill>
-                  <a:srgbClr val="F5A623"/>
+                  <a:srgbClr val="FF9900"/>
                 </a:solidFill>
                 <a:latin typeface="Calibri"/>
               </a:rPr>
@@ -13097,7 +13097,7 @@
             <a:r>
               <a:rPr sz="950" b="1" i="0">
                 <a:solidFill>
-                  <a:srgbClr val="F5A623"/>
+                  <a:srgbClr val="FF9900"/>
                 </a:solidFill>
                 <a:latin typeface="Calibri"/>
               </a:rPr>
@@ -13142,7 +13142,7 @@
             <a:r>
               <a:rPr sz="950" b="1" i="0">
                 <a:solidFill>
-                  <a:srgbClr val="F5A623"/>
+                  <a:srgbClr val="FF9900"/>
                 </a:solidFill>
                 <a:latin typeface="Calibri"/>
               </a:rPr>
@@ -13187,7 +13187,7 @@
             <a:r>
               <a:rPr sz="950" b="1" i="0">
                 <a:solidFill>
-                  <a:srgbClr val="F5A623"/>
+                  <a:srgbClr val="FF9900"/>
                 </a:solidFill>
                 <a:latin typeface="Calibri"/>
               </a:rPr>
@@ -13232,7 +13232,7 @@
             <a:r>
               <a:rPr sz="950" b="1" i="0">
                 <a:solidFill>
-                  <a:srgbClr val="F5A623"/>
+                  <a:srgbClr val="FF9900"/>
                 </a:solidFill>
                 <a:latin typeface="Calibri"/>
               </a:rPr>
@@ -13277,7 +13277,7 @@
             <a:r>
               <a:rPr sz="950" b="1" i="0">
                 <a:solidFill>
-                  <a:srgbClr val="F5A623"/>
+                  <a:srgbClr val="FF9900"/>
                 </a:solidFill>
                 <a:latin typeface="Calibri"/>
               </a:rPr>
@@ -13322,7 +13322,7 @@
             <a:r>
               <a:rPr sz="950" b="1" i="0">
                 <a:solidFill>
-                  <a:srgbClr val="F5A623"/>
+                  <a:srgbClr val="FF9900"/>
                 </a:solidFill>
                 <a:latin typeface="Calibri"/>
               </a:rPr>
@@ -13367,7 +13367,7 @@
             <a:r>
               <a:rPr sz="950" b="1" i="0">
                 <a:solidFill>
-                  <a:srgbClr val="F5A623"/>
+                  <a:srgbClr val="FF9900"/>
                 </a:solidFill>
                 <a:latin typeface="Calibri"/>
               </a:rPr>
@@ -13412,7 +13412,7 @@
             <a:r>
               <a:rPr sz="950" b="1" i="0">
                 <a:solidFill>
-                  <a:srgbClr val="F5A623"/>
+                  <a:srgbClr val="FF9900"/>
                 </a:solidFill>
                 <a:latin typeface="Calibri"/>
               </a:rPr>
@@ -13436,7 +13436,7 @@
             <a:avLst/>
           </a:prstGeom>
           <a:solidFill>
-            <a:srgbClr val="1B242F"/>
+            <a:srgbClr val="232F3E"/>
           </a:solidFill>
           <a:ln>
             <a:noFill/>
@@ -14326,7 +14326,7 @@
             <a:avLst/>
           </a:prstGeom>
           <a:solidFill>
-            <a:srgbClr val="1B242F"/>
+            <a:srgbClr val="232F3E"/>
           </a:solidFill>
           <a:ln>
             <a:noFill/>
@@ -15216,7 +15216,7 @@
             <a:avLst/>
           </a:prstGeom>
           <a:solidFill>
-            <a:srgbClr val="1B242F"/>
+            <a:srgbClr val="232F3E"/>
           </a:solidFill>
           <a:ln>
             <a:noFill/>
@@ -16106,7 +16106,7 @@
             <a:avLst/>
           </a:prstGeom>
           <a:solidFill>
-            <a:srgbClr val="1B242F"/>
+            <a:srgbClr val="232F3E"/>
           </a:solidFill>
           <a:ln>
             <a:noFill/>
@@ -16996,7 +16996,7 @@
             <a:avLst/>
           </a:prstGeom>
           <a:solidFill>
-            <a:srgbClr val="1B242F"/>
+            <a:srgbClr val="232F3E"/>
           </a:solidFill>
           <a:ln>
             <a:noFill/>
@@ -17886,7 +17886,7 @@
             <a:avLst/>
           </a:prstGeom>
           <a:solidFill>
-            <a:srgbClr val="1B242F"/>
+            <a:srgbClr val="232F3E"/>
           </a:solidFill>
           <a:ln>
             <a:noFill/>
@@ -18562,7 +18562,7 @@
             <a:r>
               <a:rPr sz="3300" b="1" i="0">
                 <a:solidFill>
-                  <a:srgbClr val="1B242F"/>
+                  <a:srgbClr val="232F3E"/>
                 </a:solidFill>
                 <a:latin typeface="Cambria"/>
               </a:rPr>
@@ -18715,7 +18715,7 @@
             <a:r>
               <a:rPr sz="1350" b="1" i="0">
                 <a:solidFill>
-                  <a:srgbClr val="1B242F"/>
+                  <a:srgbClr val="232F3E"/>
                 </a:solidFill>
                 <a:latin typeface="Calibri"/>
               </a:rPr>
@@ -18842,7 +18842,7 @@
             <a:r>
               <a:rPr sz="1350" b="1" i="0">
                 <a:solidFill>
-                  <a:srgbClr val="1B242F"/>
+                  <a:srgbClr val="232F3E"/>
                 </a:solidFill>
                 <a:latin typeface="Calibri"/>
               </a:rPr>
@@ -18969,7 +18969,7 @@
             <a:r>
               <a:rPr sz="1350" b="1" i="0">
                 <a:solidFill>
-                  <a:srgbClr val="1B242F"/>
+                  <a:srgbClr val="232F3E"/>
                 </a:solidFill>
                 <a:latin typeface="Calibri"/>
               </a:rPr>
@@ -19012,7 +19012,7 @@
             <a:avLst/>
           </a:prstGeom>
           <a:solidFill>
-            <a:srgbClr val="1B242F"/>
+            <a:srgbClr val="232F3E"/>
           </a:solidFill>
           <a:ln>
             <a:noFill/>
@@ -19077,7 +19077,7 @@
             <a:r>
               <a:rPr sz="1450" b="1" i="0">
                 <a:solidFill>
-                  <a:srgbClr val="F5A623"/>
+                  <a:srgbClr val="FF9900"/>
                 </a:solidFill>
                 <a:latin typeface="Calibri"/>
               </a:rPr>
@@ -19144,7 +19144,7 @@
             <a:r>
               <a:rPr sz="1500" b="0" i="1">
                 <a:solidFill>
-                  <a:srgbClr val="1B242F"/>
+                  <a:srgbClr val="232F3E"/>
                 </a:solidFill>
                 <a:latin typeface="Calibri"/>
               </a:rPr>
@@ -19335,7 +19335,7 @@
             <a:r>
               <a:rPr sz="3300" b="1" i="0">
                 <a:solidFill>
-                  <a:srgbClr val="1B242F"/>
+                  <a:srgbClr val="232F3E"/>
                 </a:solidFill>
                 <a:latin typeface="Cambria"/>
               </a:rPr>
@@ -19496,7 +19496,7 @@
             <a:r>
               <a:rPr sz="1650" b="1" i="0">
                 <a:solidFill>
-                  <a:srgbClr val="1B242F"/>
+                  <a:srgbClr val="232F3E"/>
                 </a:solidFill>
                 <a:latin typeface="Cambria"/>
               </a:rPr>
@@ -19679,7 +19679,7 @@
             <a:r>
               <a:rPr sz="1650" b="1" i="0">
                 <a:solidFill>
-                  <a:srgbClr val="1B242F"/>
+                  <a:srgbClr val="232F3E"/>
                 </a:solidFill>
                 <a:latin typeface="Cambria"/>
               </a:rPr>
@@ -19862,7 +19862,7 @@
             <a:r>
               <a:rPr sz="1650" b="1" i="0">
                 <a:solidFill>
-                  <a:srgbClr val="1B242F"/>
+                  <a:srgbClr val="232F3E"/>
                 </a:solidFill>
                 <a:latin typeface="Cambria"/>
               </a:rPr>
@@ -19929,7 +19929,7 @@
             <a:r>
               <a:rPr sz="1300" b="0" i="1">
                 <a:solidFill>
-                  <a:srgbClr val="1B242F"/>
+                  <a:srgbClr val="232F3E"/>
                 </a:solidFill>
                 <a:latin typeface="Calibri"/>
               </a:rPr>
@@ -20057,7 +20057,7 @@
             <a:avLst/>
           </a:prstGeom>
           <a:solidFill>
-            <a:srgbClr val="F5A623"/>
+            <a:srgbClr val="FF9900"/>
           </a:solidFill>
           <a:ln>
             <a:noFill/>
@@ -20170,7 +20170,7 @@
             <a:r>
               <a:rPr sz="2200" b="0" i="1">
                 <a:solidFill>
-                  <a:srgbClr val="F5A623"/>
+                  <a:srgbClr val="FF9900"/>
                 </a:solidFill>
                 <a:latin typeface="Cambria"/>
               </a:rPr>
@@ -20335,7 +20335,7 @@
             <a:r>
               <a:rPr sz="1250" b="1" i="0">
                 <a:solidFill>
-                  <a:srgbClr val="F5A623"/>
+                  <a:srgbClr val="FF9900"/>
                 </a:solidFill>
                 <a:latin typeface="Calibri"/>
               </a:rPr>
@@ -20404,7 +20404,7 @@
             <a:avLst/>
           </a:prstGeom>
           <a:solidFill>
-            <a:srgbClr val="1B242F"/>
+            <a:srgbClr val="232F3E"/>
           </a:solidFill>
           <a:ln>
             <a:noFill/>
@@ -20466,7 +20466,7 @@
             <a:r>
               <a:rPr sz="1500" b="1" i="0">
                 <a:solidFill>
-                  <a:srgbClr val="F5A623"/>
+                  <a:srgbClr val="FF9900"/>
                 </a:solidFill>
                 <a:latin typeface="Cambria"/>
               </a:rPr>
@@ -20485,7 +20485,7 @@
             <a:r>
               <a:rPr sz="1200" b="1" i="0">
                 <a:solidFill>
-                  <a:srgbClr val="F5A623"/>
+                  <a:srgbClr val="FF9900"/>
                 </a:solidFill>
                 <a:latin typeface="Calibri"/>
               </a:rPr>
@@ -20522,7 +20522,7 @@
             <a:r>
               <a:rPr sz="1200" b="1" i="0">
                 <a:solidFill>
-                  <a:srgbClr val="F5A623"/>
+                  <a:srgbClr val="FF9900"/>
                 </a:solidFill>
                 <a:latin typeface="Calibri"/>
               </a:rPr>
@@ -20559,7 +20559,7 @@
             <a:r>
               <a:rPr sz="1200" b="1" i="0">
                 <a:solidFill>
-                  <a:srgbClr val="F5A623"/>
+                  <a:srgbClr val="FF9900"/>
                 </a:solidFill>
                 <a:latin typeface="Calibri"/>
               </a:rPr>
@@ -20596,7 +20596,7 @@
             <a:r>
               <a:rPr sz="1200" b="1" i="0">
                 <a:solidFill>
-                  <a:srgbClr val="F5A623"/>
+                  <a:srgbClr val="FF9900"/>
                 </a:solidFill>
                 <a:latin typeface="Calibri"/>
               </a:rPr>
@@ -20633,7 +20633,7 @@
             <a:r>
               <a:rPr sz="1200" b="1" i="0">
                 <a:solidFill>
-                  <a:srgbClr val="F5A623"/>
+                  <a:srgbClr val="FF9900"/>
                 </a:solidFill>
                 <a:latin typeface="Calibri"/>
               </a:rPr>
@@ -20670,7 +20670,7 @@
             <a:r>
               <a:rPr sz="1200" b="1" i="0">
                 <a:solidFill>
-                  <a:srgbClr val="F5A623"/>
+                  <a:srgbClr val="FF9900"/>
                 </a:solidFill>
                 <a:latin typeface="Calibri"/>
               </a:rPr>
@@ -20707,7 +20707,7 @@
             <a:r>
               <a:rPr sz="1200" b="1" i="0">
                 <a:solidFill>
-                  <a:srgbClr val="F5A623"/>
+                  <a:srgbClr val="FF9900"/>
                 </a:solidFill>
                 <a:latin typeface="Calibri"/>
               </a:rPr>
@@ -20749,11 +20749,11 @@
             <a:avLst/>
           </a:prstGeom>
           <a:solidFill>
-            <a:srgbClr val="1B242F"/>
+            <a:srgbClr val="232F3E"/>
           </a:solidFill>
           <a:ln w="12700">
             <a:solidFill>
-              <a:srgbClr val="F5A623"/>
+              <a:srgbClr val="FF9900"/>
             </a:solidFill>
           </a:ln>
           <a:effectLst/>
@@ -20813,7 +20813,7 @@
             <a:r>
               <a:rPr sz="1500" b="1" i="0">
                 <a:solidFill>
-                  <a:srgbClr val="F5A623"/>
+                  <a:srgbClr val="FF9900"/>
                 </a:solidFill>
                 <a:latin typeface="Cambria"/>
               </a:rPr>
@@ -20835,7 +20835,7 @@
             <a:r>
               <a:rPr sz="1250" b="1" i="0">
                 <a:solidFill>
-                  <a:srgbClr val="F5A623"/>
+                  <a:srgbClr val="FF9900"/>
                 </a:solidFill>
                 <a:latin typeface="Calibri"/>
               </a:rPr>
@@ -20866,7 +20866,7 @@
             <a:r>
               <a:rPr sz="1250" b="1" i="0">
                 <a:solidFill>
-                  <a:srgbClr val="F5A623"/>
+                  <a:srgbClr val="FF9900"/>
                 </a:solidFill>
                 <a:latin typeface="Calibri"/>
               </a:rPr>
@@ -20897,7 +20897,7 @@
             <a:r>
               <a:rPr sz="1250" b="1" i="0">
                 <a:solidFill>
-                  <a:srgbClr val="F5A623"/>
+                  <a:srgbClr val="FF9900"/>
                 </a:solidFill>
                 <a:latin typeface="Calibri"/>
               </a:rPr>
@@ -20928,7 +20928,7 @@
             <a:r>
               <a:rPr sz="1250" b="1" i="0">
                 <a:solidFill>
-                  <a:srgbClr val="F5A623"/>
+                  <a:srgbClr val="FF9900"/>
                 </a:solidFill>
                 <a:latin typeface="Calibri"/>
               </a:rPr>
@@ -21083,7 +21083,7 @@
             <a:r>
               <a:rPr sz="1250" b="1" i="0">
                 <a:solidFill>
-                  <a:srgbClr val="F5A623"/>
+                  <a:srgbClr val="FF9900"/>
                 </a:solidFill>
                 <a:latin typeface="Calibri"/>
               </a:rPr>
@@ -21152,7 +21152,7 @@
             <a:avLst/>
           </a:prstGeom>
           <a:solidFill>
-            <a:srgbClr val="1B242F"/>
+            <a:srgbClr val="232F3E"/>
           </a:solidFill>
           <a:ln>
             <a:noFill/>
@@ -21214,7 +21214,7 @@
             <a:r>
               <a:rPr sz="1500" b="1" i="0">
                 <a:solidFill>
-                  <a:srgbClr val="F5A623"/>
+                  <a:srgbClr val="FF9900"/>
                 </a:solidFill>
                 <a:latin typeface="Cambria"/>
               </a:rPr>
@@ -21238,7 +21238,7 @@
             <a:avLst/>
           </a:prstGeom>
           <a:solidFill>
-            <a:srgbClr val="F5A623"/>
+            <a:srgbClr val="FF9900"/>
           </a:solidFill>
           <a:ln>
             <a:noFill/>
@@ -21306,7 +21306,7 @@
             <a:r>
               <a:rPr sz="1300" b="1" i="0">
                 <a:solidFill>
-                  <a:srgbClr val="F5A623"/>
+                  <a:srgbClr val="FF9900"/>
                 </a:solidFill>
                 <a:latin typeface="Cambria"/>
               </a:rPr>
@@ -21339,7 +21339,7 @@
             <a:avLst/>
           </a:prstGeom>
           <a:solidFill>
-            <a:srgbClr val="F5A623"/>
+            <a:srgbClr val="FF9900"/>
           </a:solidFill>
           <a:ln>
             <a:noFill/>
@@ -21407,7 +21407,7 @@
             <a:r>
               <a:rPr sz="1300" b="1" i="0">
                 <a:solidFill>
-                  <a:srgbClr val="F5A623"/>
+                  <a:srgbClr val="FF9900"/>
                 </a:solidFill>
                 <a:latin typeface="Cambria"/>
               </a:rPr>
@@ -21440,7 +21440,7 @@
             <a:avLst/>
           </a:prstGeom>
           <a:solidFill>
-            <a:srgbClr val="F5A623"/>
+            <a:srgbClr val="FF9900"/>
           </a:solidFill>
           <a:ln>
             <a:noFill/>
@@ -21508,7 +21508,7 @@
             <a:r>
               <a:rPr sz="1300" b="1" i="0">
                 <a:solidFill>
-                  <a:srgbClr val="F5A623"/>
+                  <a:srgbClr val="FF9900"/>
                 </a:solidFill>
                 <a:latin typeface="Cambria"/>
               </a:rPr>
@@ -21541,7 +21541,7 @@
             <a:avLst/>
           </a:prstGeom>
           <a:solidFill>
-            <a:srgbClr val="F5A623"/>
+            <a:srgbClr val="FF9900"/>
           </a:solidFill>
           <a:ln>
             <a:noFill/>
@@ -21609,7 +21609,7 @@
             <a:r>
               <a:rPr sz="1300" b="1" i="0">
                 <a:solidFill>
-                  <a:srgbClr val="F5A623"/>
+                  <a:srgbClr val="FF9900"/>
                 </a:solidFill>
                 <a:latin typeface="Cambria"/>
               </a:rPr>
@@ -21642,11 +21642,11 @@
             <a:avLst/>
           </a:prstGeom>
           <a:solidFill>
-            <a:srgbClr val="1B242F"/>
+            <a:srgbClr val="232F3E"/>
           </a:solidFill>
           <a:ln w="12700">
             <a:solidFill>
-              <a:srgbClr val="F5A623"/>
+              <a:srgbClr val="FF9900"/>
             </a:solidFill>
           </a:ln>
           <a:effectLst/>
@@ -21706,7 +21706,7 @@
             <a:r>
               <a:rPr sz="1500" b="1" i="0">
                 <a:solidFill>
-                  <a:srgbClr val="F5A623"/>
+                  <a:srgbClr val="FF9900"/>
                 </a:solidFill>
                 <a:latin typeface="Cambria"/>
               </a:rPr>
@@ -22155,7 +22155,7 @@
             <a:r>
               <a:rPr sz="1250" b="0" i="1">
                 <a:solidFill>
-                  <a:srgbClr val="F5A623"/>
+                  <a:srgbClr val="FF9900"/>
                 </a:solidFill>
                 <a:latin typeface="Calibri"/>
               </a:rPr>
@@ -22301,7 +22301,7 @@
             <a:r>
               <a:rPr sz="1250" b="1" i="0">
                 <a:solidFill>
-                  <a:srgbClr val="F5A623"/>
+                  <a:srgbClr val="FF9900"/>
                 </a:solidFill>
                 <a:latin typeface="Calibri"/>
               </a:rPr>
@@ -22412,7 +22412,7 @@
             <a:avLst/>
           </a:prstGeom>
           <a:solidFill>
-            <a:srgbClr val="1B242F"/>
+            <a:srgbClr val="232F3E"/>
           </a:solidFill>
           <a:ln w="12700">
             <a:solidFill>
@@ -22653,11 +22653,11 @@
             <a:avLst/>
           </a:prstGeom>
           <a:solidFill>
-            <a:srgbClr val="1B242F"/>
+            <a:srgbClr val="232F3E"/>
           </a:solidFill>
           <a:ln w="12700">
             <a:solidFill>
-              <a:srgbClr val="F5A623"/>
+              <a:srgbClr val="FF9900"/>
             </a:solidFill>
           </a:ln>
           <a:effectLst/>
@@ -22715,7 +22715,7 @@
             <a:r>
               <a:rPr sz="1450" b="1" i="0">
                 <a:solidFill>
-                  <a:srgbClr val="F5A623"/>
+                  <a:srgbClr val="FF9900"/>
                 </a:solidFill>
                 <a:latin typeface="Cambria"/>
               </a:rPr>
@@ -22737,7 +22737,7 @@
             <a:r>
               <a:rPr sz="1150" b="1" i="0">
                 <a:solidFill>
-                  <a:srgbClr val="F5A623"/>
+                  <a:srgbClr val="FF9900"/>
                 </a:solidFill>
                 <a:latin typeface="Calibri"/>
               </a:rPr>
@@ -22768,7 +22768,7 @@
             <a:r>
               <a:rPr sz="1150" b="1" i="0">
                 <a:solidFill>
-                  <a:srgbClr val="F5A623"/>
+                  <a:srgbClr val="FF9900"/>
                 </a:solidFill>
                 <a:latin typeface="Calibri"/>
               </a:rPr>
@@ -22799,7 +22799,7 @@
             <a:r>
               <a:rPr sz="1150" b="1" i="0">
                 <a:solidFill>
-                  <a:srgbClr val="F5A623"/>
+                  <a:srgbClr val="FF9900"/>
                 </a:solidFill>
                 <a:latin typeface="Calibri"/>
               </a:rPr>
@@ -22830,7 +22830,7 @@
             <a:r>
               <a:rPr sz="1150" b="1" i="0">
                 <a:solidFill>
-                  <a:srgbClr val="F5A623"/>
+                  <a:srgbClr val="FF9900"/>
                 </a:solidFill>
                 <a:latin typeface="Calibri"/>
               </a:rPr>
@@ -23028,7 +23028,7 @@
             <a:r>
               <a:rPr sz="1250" b="1" i="0">
                 <a:solidFill>
-                  <a:srgbClr val="F5A623"/>
+                  <a:srgbClr val="FF9900"/>
                 </a:solidFill>
                 <a:latin typeface="Calibri"/>
               </a:rPr>
@@ -23097,7 +23097,7 @@
             <a:avLst/>
           </a:prstGeom>
           <a:solidFill>
-            <a:srgbClr val="1B242F"/>
+            <a:srgbClr val="232F3E"/>
           </a:solidFill>
           <a:ln>
             <a:noFill/>
@@ -23307,11 +23307,11 @@
             <a:avLst/>
           </a:prstGeom>
           <a:solidFill>
-            <a:srgbClr val="1B242F"/>
+            <a:srgbClr val="232F3E"/>
           </a:solidFill>
           <a:ln w="12700">
             <a:solidFill>
-              <a:srgbClr val="F5A623"/>
+              <a:srgbClr val="FF9900"/>
             </a:solidFill>
           </a:ln>
           <a:effectLst/>
@@ -23371,7 +23371,7 @@
             <a:r>
               <a:rPr sz="1600" b="1" i="0">
                 <a:solidFill>
-                  <a:srgbClr val="F5A623"/>
+                  <a:srgbClr val="FF9900"/>
                 </a:solidFill>
                 <a:latin typeface="Cambria"/>
               </a:rPr>
@@ -23393,7 +23393,7 @@
             <a:r>
               <a:rPr sz="1450" b="1" i="0">
                 <a:solidFill>
-                  <a:srgbClr val="F5A623"/>
+                  <a:srgbClr val="FF9900"/>
                 </a:solidFill>
                 <a:latin typeface="Calibri"/>
               </a:rPr>
@@ -23424,7 +23424,7 @@
             <a:r>
               <a:rPr sz="1450" b="1" i="0">
                 <a:solidFill>
-                  <a:srgbClr val="F5A623"/>
+                  <a:srgbClr val="FF9900"/>
                 </a:solidFill>
                 <a:latin typeface="Calibri"/>
               </a:rPr>
@@ -23455,7 +23455,7 @@
             <a:r>
               <a:rPr sz="1450" b="1" i="0">
                 <a:solidFill>
-                  <a:srgbClr val="F5A623"/>
+                  <a:srgbClr val="FF9900"/>
                 </a:solidFill>
                 <a:latin typeface="Calibri"/>
               </a:rPr>
@@ -23486,7 +23486,7 @@
             <a:r>
               <a:rPr sz="1450" b="1" i="0">
                 <a:solidFill>
-                  <a:srgbClr val="F5A623"/>
+                  <a:srgbClr val="FF9900"/>
                 </a:solidFill>
                 <a:latin typeface="Calibri"/>
               </a:rPr>
@@ -23686,7 +23686,7 @@
             <a:r>
               <a:rPr sz="1250" b="1" i="0">
                 <a:solidFill>
-                  <a:srgbClr val="F5A623"/>
+                  <a:srgbClr val="FF9900"/>
                 </a:solidFill>
                 <a:latin typeface="Calibri"/>
               </a:rPr>
@@ -23755,7 +23755,7 @@
             <a:avLst/>
           </a:prstGeom>
           <a:solidFill>
-            <a:srgbClr val="1B242F"/>
+            <a:srgbClr val="232F3E"/>
           </a:solidFill>
           <a:ln>
             <a:noFill/>
@@ -23799,7 +23799,7 @@
             <a:avLst/>
           </a:prstGeom>
           <a:solidFill>
-            <a:srgbClr val="F5A623"/>
+            <a:srgbClr val="FF9900"/>
           </a:solidFill>
           <a:ln>
             <a:noFill/>
@@ -23873,7 +23873,7 @@
             <a:r>
               <a:rPr sz="1450" b="1" i="0">
                 <a:solidFill>
-                  <a:srgbClr val="F5A623"/>
+                  <a:srgbClr val="FF9900"/>
                 </a:solidFill>
                 <a:latin typeface="Cambria"/>
               </a:rPr>
@@ -23986,7 +23986,7 @@
             <a:avLst/>
           </a:prstGeom>
           <a:solidFill>
-            <a:srgbClr val="F5A623"/>
+            <a:srgbClr val="FF9900"/>
           </a:solidFill>
           <a:ln>
             <a:noFill/>
@@ -24060,7 +24060,7 @@
             <a:r>
               <a:rPr sz="1450" b="1" i="0">
                 <a:solidFill>
-                  <a:srgbClr val="F5A623"/>
+                  <a:srgbClr val="FF9900"/>
                 </a:solidFill>
                 <a:latin typeface="Cambria"/>
               </a:rPr>
@@ -24129,7 +24129,7 @@
             <a:avLst/>
           </a:prstGeom>
           <a:solidFill>
-            <a:srgbClr val="1B242F"/>
+            <a:srgbClr val="232F3E"/>
           </a:solidFill>
           <a:ln>
             <a:noFill/>
@@ -24173,7 +24173,7 @@
             <a:avLst/>
           </a:prstGeom>
           <a:solidFill>
-            <a:srgbClr val="F5A623"/>
+            <a:srgbClr val="FF9900"/>
           </a:solidFill>
           <a:ln>
             <a:noFill/>
@@ -24247,7 +24247,7 @@
             <a:r>
               <a:rPr sz="1450" b="1" i="0">
                 <a:solidFill>
-                  <a:srgbClr val="F5A623"/>
+                  <a:srgbClr val="FF9900"/>
                 </a:solidFill>
                 <a:latin typeface="Cambria"/>
               </a:rPr>
@@ -24360,7 +24360,7 @@
             <a:avLst/>
           </a:prstGeom>
           <a:solidFill>
-            <a:srgbClr val="F5A623"/>
+            <a:srgbClr val="FF9900"/>
           </a:solidFill>
           <a:ln>
             <a:noFill/>
@@ -24434,7 +24434,7 @@
             <a:r>
               <a:rPr sz="1450" b="1" i="0">
                 <a:solidFill>
-                  <a:srgbClr val="F5A623"/>
+                  <a:srgbClr val="FF9900"/>
                 </a:solidFill>
                 <a:latin typeface="Cambria"/>
               </a:rPr>
@@ -24503,7 +24503,7 @@
             <a:avLst/>
           </a:prstGeom>
           <a:solidFill>
-            <a:srgbClr val="1B242F"/>
+            <a:srgbClr val="232F3E"/>
           </a:solidFill>
           <a:ln>
             <a:noFill/>
@@ -24547,7 +24547,7 @@
             <a:avLst/>
           </a:prstGeom>
           <a:solidFill>
-            <a:srgbClr val="F5A623"/>
+            <a:srgbClr val="FF9900"/>
           </a:solidFill>
           <a:ln>
             <a:noFill/>
@@ -24621,7 +24621,7 @@
             <a:r>
               <a:rPr sz="1450" b="1" i="0">
                 <a:solidFill>
-                  <a:srgbClr val="F5A623"/>
+                  <a:srgbClr val="FF9900"/>
                 </a:solidFill>
                 <a:latin typeface="Cambria"/>
               </a:rPr>
@@ -24812,7 +24812,7 @@
             <a:r>
               <a:rPr sz="1250" b="1" i="0">
                 <a:solidFill>
-                  <a:srgbClr val="F5A623"/>
+                  <a:srgbClr val="FF9900"/>
                 </a:solidFill>
                 <a:latin typeface="Calibri"/>
               </a:rPr>
@@ -24881,7 +24881,7 @@
             <a:avLst/>
           </a:prstGeom>
           <a:solidFill>
-            <a:srgbClr val="1B242F"/>
+            <a:srgbClr val="232F3E"/>
           </a:solidFill>
           <a:ln>
             <a:noFill/>
@@ -24946,7 +24946,7 @@
             <a:r>
               <a:rPr sz="1150" b="1" i="0">
                 <a:solidFill>
-                  <a:srgbClr val="F5A623"/>
+                  <a:srgbClr val="FF9900"/>
                 </a:solidFill>
                 <a:latin typeface="Cambria"/>
               </a:rPr>
@@ -24993,7 +24993,7 @@
             <a:avLst/>
           </a:prstGeom>
           <a:solidFill>
-            <a:srgbClr val="F5A623"/>
+            <a:srgbClr val="FF9900"/>
           </a:solidFill>
           <a:ln>
             <a:noFill/>
@@ -25037,7 +25037,7 @@
             <a:avLst/>
           </a:prstGeom>
           <a:solidFill>
-            <a:srgbClr val="1B242F"/>
+            <a:srgbClr val="232F3E"/>
           </a:solidFill>
           <a:ln>
             <a:noFill/>
@@ -25102,7 +25102,7 @@
             <a:r>
               <a:rPr sz="1150" b="1" i="0">
                 <a:solidFill>
-                  <a:srgbClr val="F5A623"/>
+                  <a:srgbClr val="FF9900"/>
                 </a:solidFill>
                 <a:latin typeface="Cambria"/>
               </a:rPr>
@@ -25149,7 +25149,7 @@
             <a:avLst/>
           </a:prstGeom>
           <a:solidFill>
-            <a:srgbClr val="F5A623"/>
+            <a:srgbClr val="FF9900"/>
           </a:solidFill>
           <a:ln>
             <a:noFill/>
@@ -25193,7 +25193,7 @@
             <a:avLst/>
           </a:prstGeom>
           <a:solidFill>
-            <a:srgbClr val="F5A623"/>
+            <a:srgbClr val="FF9900"/>
           </a:solidFill>
           <a:ln>
             <a:noFill/>
@@ -25305,7 +25305,7 @@
             <a:avLst/>
           </a:prstGeom>
           <a:solidFill>
-            <a:srgbClr val="F5A623"/>
+            <a:srgbClr val="FF9900"/>
           </a:solidFill>
           <a:ln>
             <a:noFill/>
@@ -25349,7 +25349,7 @@
             <a:avLst/>
           </a:prstGeom>
           <a:solidFill>
-            <a:srgbClr val="1B242F"/>
+            <a:srgbClr val="232F3E"/>
           </a:solidFill>
           <a:ln>
             <a:noFill/>
@@ -25414,7 +25414,7 @@
             <a:r>
               <a:rPr sz="1150" b="1" i="0">
                 <a:solidFill>
-                  <a:srgbClr val="F5A623"/>
+                  <a:srgbClr val="FF9900"/>
                 </a:solidFill>
                 <a:latin typeface="Cambria"/>
               </a:rPr>
@@ -25461,7 +25461,7 @@
             <a:avLst/>
           </a:prstGeom>
           <a:solidFill>
-            <a:srgbClr val="F5A623"/>
+            <a:srgbClr val="FF9900"/>
           </a:solidFill>
           <a:ln>
             <a:noFill/>
@@ -25505,7 +25505,7 @@
             <a:avLst/>
           </a:prstGeom>
           <a:solidFill>
-            <a:srgbClr val="1B242F"/>
+            <a:srgbClr val="232F3E"/>
           </a:solidFill>
           <a:ln>
             <a:noFill/>
@@ -25570,7 +25570,7 @@
             <a:r>
               <a:rPr sz="1150" b="1" i="0">
                 <a:solidFill>
-                  <a:srgbClr val="F5A623"/>
+                  <a:srgbClr val="FF9900"/>
                 </a:solidFill>
                 <a:latin typeface="Cambria"/>
               </a:rPr>
@@ -25617,7 +25617,7 @@
             <a:avLst/>
           </a:prstGeom>
           <a:solidFill>
-            <a:srgbClr val="F5A623"/>
+            <a:srgbClr val="FF9900"/>
           </a:solidFill>
           <a:ln>
             <a:noFill/>
@@ -25661,7 +25661,7 @@
             <a:avLst/>
           </a:prstGeom>
           <a:solidFill>
-            <a:srgbClr val="1B242F"/>
+            <a:srgbClr val="232F3E"/>
           </a:solidFill>
           <a:ln>
             <a:noFill/>
@@ -25726,7 +25726,7 @@
             <a:r>
               <a:rPr sz="1150" b="1" i="0">
                 <a:solidFill>
-                  <a:srgbClr val="F5A623"/>
+                  <a:srgbClr val="FF9900"/>
                 </a:solidFill>
                 <a:latin typeface="Cambria"/>
               </a:rPr>
@@ -25788,7 +25788,7 @@
             <a:r>
               <a:rPr sz="1200" b="1" i="0">
                 <a:solidFill>
-                  <a:srgbClr val="F5A623"/>
+                  <a:srgbClr val="FF9900"/>
                 </a:solidFill>
                 <a:latin typeface="Calibri"/>
               </a:rPr>
@@ -25836,7 +25836,7 @@
             <a:r>
               <a:rPr sz="1200" b="1" i="0">
                 <a:solidFill>
-                  <a:srgbClr val="F5A623"/>
+                  <a:srgbClr val="FF9900"/>
                 </a:solidFill>
                 <a:latin typeface="Calibri"/>
               </a:rPr>
@@ -25884,7 +25884,7 @@
             <a:r>
               <a:rPr sz="1200" b="1" i="0">
                 <a:solidFill>
-                  <a:srgbClr val="F5A623"/>
+                  <a:srgbClr val="FF9900"/>
                 </a:solidFill>
                 <a:latin typeface="Calibri"/>
               </a:rPr>
@@ -25932,7 +25932,7 @@
             <a:r>
               <a:rPr sz="1200" b="1" i="0">
                 <a:solidFill>
-                  <a:srgbClr val="F5A623"/>
+                  <a:srgbClr val="FF9900"/>
                 </a:solidFill>
                 <a:latin typeface="Calibri"/>
               </a:rPr>
@@ -25980,7 +25980,7 @@
             <a:r>
               <a:rPr sz="1200" b="1" i="0">
                 <a:solidFill>
-                  <a:srgbClr val="F5A623"/>
+                  <a:srgbClr val="FF9900"/>
                 </a:solidFill>
                 <a:latin typeface="Calibri"/>
               </a:rPr>
@@ -26028,7 +26028,7 @@
             <a:r>
               <a:rPr sz="1200" b="1" i="0">
                 <a:solidFill>
-                  <a:srgbClr val="F5A623"/>
+                  <a:srgbClr val="FF9900"/>
                 </a:solidFill>
                 <a:latin typeface="Calibri"/>
               </a:rPr>
@@ -26115,7 +26115,7 @@
             <a:r>
               <a:rPr sz="1200" b="1" i="0">
                 <a:solidFill>
-                  <a:srgbClr val="F5A623"/>
+                  <a:srgbClr val="FF9900"/>
                 </a:solidFill>
                 <a:latin typeface="Calibri"/>
               </a:rPr>
@@ -26270,7 +26270,7 @@
             <a:r>
               <a:rPr sz="1250" b="1" i="0">
                 <a:solidFill>
-                  <a:srgbClr val="F5A623"/>
+                  <a:srgbClr val="FF9900"/>
                 </a:solidFill>
                 <a:latin typeface="Calibri"/>
               </a:rPr>
@@ -26401,7 +26401,7 @@
             <a:r>
               <a:rPr sz="1500" b="1" i="0">
                 <a:solidFill>
-                  <a:srgbClr val="F5A623"/>
+                  <a:srgbClr val="FF9900"/>
                 </a:solidFill>
                 <a:latin typeface="Consolas"/>
               </a:rPr>
@@ -26642,7 +26642,7 @@
             <a:avLst/>
           </a:prstGeom>
           <a:solidFill>
-            <a:srgbClr val="1B242F"/>
+            <a:srgbClr val="232F3E"/>
           </a:solidFill>
           <a:ln>
             <a:noFill/>
@@ -26686,7 +26686,7 @@
             <a:avLst/>
           </a:prstGeom>
           <a:solidFill>
-            <a:srgbClr val="F5A623"/>
+            <a:srgbClr val="FF9900"/>
           </a:solidFill>
           <a:ln>
             <a:noFill/>
@@ -26760,7 +26760,7 @@
             <a:r>
               <a:rPr sz="1350" b="1" i="0">
                 <a:solidFill>
-                  <a:srgbClr val="F5A623"/>
+                  <a:srgbClr val="FF9900"/>
                 </a:solidFill>
                 <a:latin typeface="Cambria"/>
               </a:rPr>
@@ -26806,7 +26806,7 @@
             <a:avLst/>
           </a:prstGeom>
           <a:solidFill>
-            <a:srgbClr val="1B242F"/>
+            <a:srgbClr val="232F3E"/>
           </a:solidFill>
           <a:ln>
             <a:noFill/>
@@ -26850,7 +26850,7 @@
             <a:avLst/>
           </a:prstGeom>
           <a:solidFill>
-            <a:srgbClr val="F5A623"/>
+            <a:srgbClr val="FF9900"/>
           </a:solidFill>
           <a:ln>
             <a:noFill/>
@@ -26924,7 +26924,7 @@
             <a:r>
               <a:rPr sz="1350" b="1" i="0">
                 <a:solidFill>
-                  <a:srgbClr val="F5A623"/>
+                  <a:srgbClr val="FF9900"/>
                 </a:solidFill>
                 <a:latin typeface="Cambria"/>
               </a:rPr>
@@ -26970,7 +26970,7 @@
             <a:avLst/>
           </a:prstGeom>
           <a:solidFill>
-            <a:srgbClr val="1B242F"/>
+            <a:srgbClr val="232F3E"/>
           </a:solidFill>
           <a:ln>
             <a:noFill/>
@@ -27014,7 +27014,7 @@
             <a:avLst/>
           </a:prstGeom>
           <a:solidFill>
-            <a:srgbClr val="F5A623"/>
+            <a:srgbClr val="FF9900"/>
           </a:solidFill>
           <a:ln>
             <a:noFill/>
@@ -27088,7 +27088,7 @@
             <a:r>
               <a:rPr sz="1350" b="1" i="0">
                 <a:solidFill>
-                  <a:srgbClr val="F5A623"/>
+                  <a:srgbClr val="FF9900"/>
                 </a:solidFill>
                 <a:latin typeface="Cambria"/>
               </a:rPr>
@@ -27301,7 +27301,7 @@
             <a:r>
               <a:rPr sz="3300" b="1" i="0">
                 <a:solidFill>
-                  <a:srgbClr val="1B242F"/>
+                  <a:srgbClr val="232F3E"/>
                 </a:solidFill>
                 <a:latin typeface="Cambria"/>
               </a:rPr>
@@ -27369,7 +27369,7 @@
             <a:avLst/>
           </a:prstGeom>
           <a:solidFill>
-            <a:srgbClr val="F5A623"/>
+            <a:srgbClr val="FF9900"/>
           </a:solidFill>
           <a:ln>
             <a:noFill/>
@@ -27440,7 +27440,7 @@
             <a:r>
               <a:rPr sz="1600" b="1" i="0">
                 <a:solidFill>
-                  <a:srgbClr val="1B242F"/>
+                  <a:srgbClr val="232F3E"/>
                 </a:solidFill>
                 <a:latin typeface="Cambria"/>
               </a:rPr>
@@ -27595,7 +27595,7 @@
             <a:avLst/>
           </a:prstGeom>
           <a:solidFill>
-            <a:srgbClr val="F5A623"/>
+            <a:srgbClr val="FF9900"/>
           </a:solidFill>
           <a:ln>
             <a:noFill/>
@@ -27666,7 +27666,7 @@
             <a:r>
               <a:rPr sz="1600" b="1" i="0">
                 <a:solidFill>
-                  <a:srgbClr val="1B242F"/>
+                  <a:srgbClr val="232F3E"/>
                 </a:solidFill>
                 <a:latin typeface="Cambria"/>
               </a:rPr>
@@ -27821,7 +27821,7 @@
             <a:avLst/>
           </a:prstGeom>
           <a:solidFill>
-            <a:srgbClr val="F5A623"/>
+            <a:srgbClr val="FF9900"/>
           </a:solidFill>
           <a:ln>
             <a:noFill/>
@@ -27892,7 +27892,7 @@
             <a:r>
               <a:rPr sz="1600" b="1" i="0">
                 <a:solidFill>
-                  <a:srgbClr val="1B242F"/>
+                  <a:srgbClr val="232F3E"/>
                 </a:solidFill>
                 <a:latin typeface="Cambria"/>
               </a:rPr>
@@ -28047,7 +28047,7 @@
             <a:avLst/>
           </a:prstGeom>
           <a:solidFill>
-            <a:srgbClr val="F5A623"/>
+            <a:srgbClr val="FF9900"/>
           </a:solidFill>
           <a:ln>
             <a:noFill/>
@@ -28118,7 +28118,7 @@
             <a:r>
               <a:rPr sz="1600" b="1" i="0">
                 <a:solidFill>
-                  <a:srgbClr val="1B242F"/>
+                  <a:srgbClr val="232F3E"/>
                 </a:solidFill>
                 <a:latin typeface="Cambria"/>
               </a:rPr>
@@ -28273,7 +28273,7 @@
             <a:avLst/>
           </a:prstGeom>
           <a:solidFill>
-            <a:srgbClr val="F5A623"/>
+            <a:srgbClr val="FF9900"/>
           </a:solidFill>
           <a:ln>
             <a:noFill/>
@@ -28344,7 +28344,7 @@
             <a:r>
               <a:rPr sz="1600" b="1" i="0">
                 <a:solidFill>
-                  <a:srgbClr val="1B242F"/>
+                  <a:srgbClr val="232F3E"/>
                 </a:solidFill>
                 <a:latin typeface="Cambria"/>
               </a:rPr>
@@ -28577,7 +28577,7 @@
             <a:r>
               <a:rPr sz="1250" b="1" i="0">
                 <a:solidFill>
-                  <a:srgbClr val="F5A623"/>
+                  <a:srgbClr val="FF9900"/>
                 </a:solidFill>
                 <a:latin typeface="Calibri"/>
               </a:rPr>
@@ -28691,7 +28691,7 @@
             <a:avLst/>
           </a:prstGeom>
           <a:solidFill>
-            <a:srgbClr val="1B242F"/>
+            <a:srgbClr val="232F3E"/>
           </a:solidFill>
           <a:ln>
             <a:noFill/>
@@ -28756,7 +28756,7 @@
             <a:r>
               <a:rPr sz="1450" b="1" i="0">
                 <a:solidFill>
-                  <a:srgbClr val="F5A623"/>
+                  <a:srgbClr val="FF9900"/>
                 </a:solidFill>
                 <a:latin typeface="Consolas"/>
               </a:rPr>
@@ -28847,7 +28847,7 @@
             <a:avLst/>
           </a:prstGeom>
           <a:solidFill>
-            <a:srgbClr val="1B242F"/>
+            <a:srgbClr val="232F3E"/>
           </a:solidFill>
           <a:ln>
             <a:noFill/>
@@ -28912,7 +28912,7 @@
             <a:r>
               <a:rPr sz="1450" b="1" i="0">
                 <a:solidFill>
-                  <a:srgbClr val="F5A623"/>
+                  <a:srgbClr val="FF9900"/>
                 </a:solidFill>
                 <a:latin typeface="Consolas"/>
               </a:rPr>
@@ -29003,7 +29003,7 @@
             <a:avLst/>
           </a:prstGeom>
           <a:solidFill>
-            <a:srgbClr val="1B242F"/>
+            <a:srgbClr val="232F3E"/>
           </a:solidFill>
           <a:ln>
             <a:noFill/>
@@ -29068,7 +29068,7 @@
             <a:r>
               <a:rPr sz="1450" b="1" i="0">
                 <a:solidFill>
-                  <a:srgbClr val="F5A623"/>
+                  <a:srgbClr val="FF9900"/>
                 </a:solidFill>
                 <a:latin typeface="Consolas"/>
               </a:rPr>
@@ -29159,7 +29159,7 @@
             <a:avLst/>
           </a:prstGeom>
           <a:solidFill>
-            <a:srgbClr val="1B242F"/>
+            <a:srgbClr val="232F3E"/>
           </a:solidFill>
           <a:ln>
             <a:noFill/>
@@ -29224,7 +29224,7 @@
             <a:r>
               <a:rPr sz="1450" b="1" i="0">
                 <a:solidFill>
-                  <a:srgbClr val="F5A623"/>
+                  <a:srgbClr val="FF9900"/>
                 </a:solidFill>
                 <a:latin typeface="Consolas"/>
               </a:rPr>
@@ -29479,7 +29479,7 @@
             <a:r>
               <a:rPr sz="1250" b="1" i="0">
                 <a:solidFill>
-                  <a:srgbClr val="F5A623"/>
+                  <a:srgbClr val="FF9900"/>
                 </a:solidFill>
                 <a:latin typeface="Calibri"/>
               </a:rPr>
@@ -29548,7 +29548,7 @@
             <a:avLst/>
           </a:prstGeom>
           <a:solidFill>
-            <a:srgbClr val="F5A623"/>
+            <a:srgbClr val="FF9900"/>
           </a:solidFill>
           <a:ln>
             <a:noFill/>
@@ -29601,7 +29601,7 @@
             <a:avLst/>
           </a:prstGeom>
           <a:solidFill>
-            <a:srgbClr val="1B242F"/>
+            <a:srgbClr val="232F3E"/>
           </a:solidFill>
           <a:ln>
             <a:noFill/>
@@ -29666,7 +29666,7 @@
             <a:r>
               <a:rPr sz="1400" b="1" i="0">
                 <a:solidFill>
-                  <a:srgbClr val="F5A623"/>
+                  <a:srgbClr val="FF9900"/>
                 </a:solidFill>
                 <a:latin typeface="Cambria"/>
               </a:rPr>
@@ -29780,7 +29780,7 @@
             <a:avLst/>
           </a:prstGeom>
           <a:solidFill>
-            <a:srgbClr val="F5A623"/>
+            <a:srgbClr val="FF9900"/>
           </a:solidFill>
           <a:ln>
             <a:noFill/>
@@ -29898,7 +29898,7 @@
             <a:r>
               <a:rPr sz="1400" b="1" i="0">
                 <a:solidFill>
-                  <a:srgbClr val="F5A623"/>
+                  <a:srgbClr val="FF9900"/>
                 </a:solidFill>
                 <a:latin typeface="Cambria"/>
               </a:rPr>
@@ -30012,7 +30012,7 @@
             <a:avLst/>
           </a:prstGeom>
           <a:solidFill>
-            <a:srgbClr val="F5A623"/>
+            <a:srgbClr val="FF9900"/>
           </a:solidFill>
           <a:ln>
             <a:noFill/>
@@ -30065,7 +30065,7 @@
             <a:avLst/>
           </a:prstGeom>
           <a:solidFill>
-            <a:srgbClr val="1B242F"/>
+            <a:srgbClr val="232F3E"/>
           </a:solidFill>
           <a:ln>
             <a:noFill/>
@@ -30130,7 +30130,7 @@
             <a:r>
               <a:rPr sz="1400" b="1" i="0">
                 <a:solidFill>
-                  <a:srgbClr val="F5A623"/>
+                  <a:srgbClr val="FF9900"/>
                 </a:solidFill>
                 <a:latin typeface="Cambria"/>
               </a:rPr>
@@ -30244,7 +30244,7 @@
             <a:avLst/>
           </a:prstGeom>
           <a:solidFill>
-            <a:srgbClr val="F5A623"/>
+            <a:srgbClr val="FF9900"/>
           </a:solidFill>
           <a:ln>
             <a:noFill/>
@@ -30362,7 +30362,7 @@
             <a:r>
               <a:rPr sz="1400" b="1" i="0">
                 <a:solidFill>
-                  <a:srgbClr val="F5A623"/>
+                  <a:srgbClr val="FF9900"/>
                 </a:solidFill>
                 <a:latin typeface="Cambria"/>
               </a:rPr>
@@ -30476,7 +30476,7 @@
             <a:avLst/>
           </a:prstGeom>
           <a:solidFill>
-            <a:srgbClr val="F5A623"/>
+            <a:srgbClr val="FF9900"/>
           </a:solidFill>
           <a:ln>
             <a:noFill/>
@@ -30529,7 +30529,7 @@
             <a:avLst/>
           </a:prstGeom>
           <a:solidFill>
-            <a:srgbClr val="1B242F"/>
+            <a:srgbClr val="232F3E"/>
           </a:solidFill>
           <a:ln>
             <a:noFill/>
@@ -30594,7 +30594,7 @@
             <a:r>
               <a:rPr sz="1400" b="1" i="0">
                 <a:solidFill>
-                  <a:srgbClr val="F5A623"/>
+                  <a:srgbClr val="FF9900"/>
                 </a:solidFill>
                 <a:latin typeface="Cambria"/>
               </a:rPr>
@@ -30708,7 +30708,7 @@
             <a:avLst/>
           </a:prstGeom>
           <a:solidFill>
-            <a:srgbClr val="F5A623"/>
+            <a:srgbClr val="FF9900"/>
           </a:solidFill>
           <a:ln>
             <a:noFill/>
@@ -30826,7 +30826,7 @@
             <a:r>
               <a:rPr sz="1400" b="1" i="0">
                 <a:solidFill>
-                  <a:srgbClr val="F5A623"/>
+                  <a:srgbClr val="FF9900"/>
                 </a:solidFill>
                 <a:latin typeface="Cambria"/>
               </a:rPr>
@@ -30961,7 +30961,7 @@
             <a:r>
               <a:rPr sz="1300" b="1" i="1">
                 <a:solidFill>
-                  <a:srgbClr val="F5A623"/>
+                  <a:srgbClr val="FF9900"/>
                 </a:solidFill>
                 <a:latin typeface="Calibri"/>
               </a:rPr>
@@ -31031,28 +31031,28 @@
         <a:sysClr val="window" lastClr="FFFFFF"/>
       </a:lt1>
       <a:dk2>
-        <a:srgbClr val="1F497D"/>
+        <a:srgbClr val="232F3E"/>
       </a:dk2>
       <a:lt2>
         <a:srgbClr val="EEECE1"/>
       </a:lt2>
       <a:accent1>
-        <a:srgbClr val="4F81BD"/>
+        <a:srgbClr val="FF9900"/>
       </a:accent1>
       <a:accent2>
-        <a:srgbClr val="C0504D"/>
+        <a:srgbClr val="232F3E"/>
       </a:accent2>
       <a:accent3>
-        <a:srgbClr val="9BBB59"/>
+        <a:srgbClr val="01A88D"/>
       </a:accent3>
       <a:accent4>
-        <a:srgbClr val="8064A2"/>
+        <a:srgbClr val="8C4FFF"/>
       </a:accent4>
       <a:accent5>
-        <a:srgbClr val="4BACC6"/>
+        <a:srgbClr val="DD344C"/>
       </a:accent5>
       <a:accent6>
-        <a:srgbClr val="F79646"/>
+        <a:srgbClr val="ED7100"/>
       </a:accent6>
       <a:hlink>
         <a:srgbClr val="0000FF"/>
@@ -31351,28 +31351,28 @@
         <a:sysClr val="window" lastClr="FFFFFF"/>
       </a:lt1>
       <a:dk2>
-        <a:srgbClr val="1F497D"/>
+        <a:srgbClr val="232F3E"/>
       </a:dk2>
       <a:lt2>
         <a:srgbClr val="EEECE1"/>
       </a:lt2>
       <a:accent1>
-        <a:srgbClr val="4F81BD"/>
+        <a:srgbClr val="FF9900"/>
       </a:accent1>
       <a:accent2>
-        <a:srgbClr val="C0504D"/>
+        <a:srgbClr val="232F3E"/>
       </a:accent2>
       <a:accent3>
-        <a:srgbClr val="9BBB59"/>
+        <a:srgbClr val="01A88D"/>
       </a:accent3>
       <a:accent4>
-        <a:srgbClr val="8064A2"/>
+        <a:srgbClr val="8C4FFF"/>
       </a:accent4>
       <a:accent5>
-        <a:srgbClr val="4BACC6"/>
+        <a:srgbClr val="DD344C"/>
       </a:accent5>
       <a:accent6>
-        <a:srgbClr val="F79646"/>
+        <a:srgbClr val="ED7100"/>
       </a:accent6>
       <a:hlink>
         <a:srgbClr val="0000FF"/>

</xml_diff>